<commit_message>
Add original and turn-weighted loss formulas to slide 07 and compiled deck
</commit_message>
<xml_diff>
--- a/presentations/slide07_turn_weighting_cn.pptx
+++ b/presentations/slide07_turn_weighting_cn.pptx
@@ -502,32 +502,37 @@
           <a:lstStyle/>
           <a:p>
             <a:r>
-              <a:t>第7页，独立单页文件。来源main c1b3750，train/logs/revalidation/P3_training_batch.md、p3_morning_metrics.csv、p3_morning_table.txt；另核对train/analyze_p3_morning_table.py。</a:t>
-            </a:r>
-          </a:p>
-          <a:p>
-            <a:r>
-              <a:t>B/C/D共享：ctx2、从e60初始化、30ep、batch128，B turn_strict x2，C x3，D累计转角三分位权重1/1.5/3。参考ctx2在CSV标为SeedA，B/C/D标为Seed0；未建立重复种子平均效果，不能声称统计显著或所有条件严格同seed。</a:t>
-            </a:r>
-          </a:p>
-          <a:p>
-            <a:r>
-              <a:t>Val all_far n=5110、turn_strict n=2751（对应P2验证材料）。val_gt45_pct由所有far误差err&gt;45计算，不是turn子集比例，因此不能直接与第6页14.5/14.9/12.6%的turn比例混用。这里ctx2全量7.08%，B8.04%，C7.44%，D7.75%。</a:t>
-            </a:r>
-          </a:p>
-          <a:p>
-            <a:r>
-              <a:t>ctx2/B/C/D的turn median为13.02/12.11/12.55/11.98deg；turn P90为53.12/55.77/54.01/53.95deg。中位误差下降但P90和全量&gt;45比例没有优于参考；不声称所有尾部指标均下降或全部恶化，因为C的P95=80.88优于ctx2的82.67。</a:t>
-            </a:r>
-          </a:p>
-          <a:p>
-            <a:r>
-              <a:t>本页仅Val筛查结果，不提供缺失的B/C/D locked utility，不与之后turnhard的2.93cm混同。后续turnhard包含不同训练配方，另页展示。</a:t>
-            </a:r>
-          </a:p>
-          <a:p>
-            <a:r>
-              <a:t>表格与卡片均可编辑；数值从原始CSV读取后保留2位小数。</a:t>
+              <a:t>第7页公式修订：原损失L_orig=sum(b_i*l_i)/sum(b_i)；新损失L_new=sum(b_i*alpha_i*l_i)/sum(b_i*alpha_i)。两者都按权重和归一化，不是把整个loss或绝对梯度直接乘2/3。</a:t>
+            </a:r>
+          </a:p>
+          <a:p>
+            <a:r>
+              <a:t>代码来源main c1b3750：train/train_goal_dino.py:run_epoch中基础b_i=steps_dev/FAR_STEPS，训练时乘turn_strict系数或curvature tier；train/train_goal_dir.py:direction_loss中(per_sample*weight).sum()/weight.sum()。</a:t>
+            </a:r>
+          </a:p>
+          <a:p>
+            <a:r>
+              <a:t>l_i预热阶段1-cos(theta_i)，之后为von Mises NLL -kappa_i*cos(theta_i)+log I0(kappa_i)，省略常数log2pi；theta为预测WP相对真实endpoint方位的夹角，I0为0阶第一类修正贝塞尔函数。kappa是模型预测集中度，不是本次训练加权alpha。</a:t>
+            </a:r>
+          </a:p>
+          <a:p>
+            <a:r>
+              <a:t>B strictturn alpha2、C alpha3，其他1；strictturn来自GT endpoint lateral&gt;=.30m OR abs yawchange&gt;=45deg。D在训练帧累计绝对转角的33.333/66.667分位点按1/1.5/3分档，实际不是按每米曲率计算，故主页面改称累计转角分档。B/C/D独立方案，不将三个权重叠乘为同一实验。</a:t>
+            </a:r>
+          </a:p>
+          <a:p>
+            <a:r>
+              <a:t>保留P3_training_batch.md与p3_morning_metrics.csv原始Val结果：ctx2/B/C/D的turn median13.02/12.11/12.55/11.98deg，turn P9053.12/55.77/54.01/53.95deg；全量&gt;45比例7.08/8.04/7.44/7.75%。</a:t>
+            </a:r>
+          </a:p>
+          <a:p>
+            <a:r>
+              <a:t>Val allfar n5110、turn n2751；全量&gt;45比例不能与第6页turn子集比例混用。ctx2参考标SeedA，B/C/D标Seed0，未建立多种子显著性，不与后续turnhard组合训练混为同一配方。C的P95有改善，故结论只针对展示的P90和全量&gt;45，不声称所有尾部指标都变差。</a:t>
+            </a:r>
+          </a:p>
+          <a:p>
+            <a:r>
+              <a:t>所有公式采用原生可编辑文本+分数线，结果表仍可编辑。新增alpha仅用于训练，验证取消额外turn/curvature权重，保留原评估规则。</a:t>
             </a:r>
           </a:p>
           <a:p/>
@@ -3665,7 +3670,7 @@
               </a:defRPr>
             </a:pPr>
             <a:r>
-              <a:t>P3 / 面向转弯场景的加权训练</a:t>
+              <a:t>P3 / 转弯加权：公式与验证结果</a:t>
             </a:r>
           </a:p>
         </p:txBody>
@@ -3737,7 +3742,7 @@
               <a:spcAft>
                 <a:spcPts val="700"/>
               </a:spcAft>
-              <a:defRPr sz="1400" b="0">
+              <a:defRPr sz="1300" b="0">
                 <a:solidFill>
                   <a:srgbClr val="62748A"/>
                 </a:solidFill>
@@ -3745,7 +3750,7 @@
               </a:defRPr>
             </a:pPr>
             <a:r>
-              <a:t>在 ctx2 架构上调整训练损失权重 · 保持主策略冻结 · 本页仅比较 Val 结果</a:t>
+              <a:t>单样本方向损失不变；在原有距离权重上，再乘转弯权重，让难例对训练影响更大。</a:t>
             </a:r>
           </a:p>
         </p:txBody>
@@ -3758,8 +3763,8 @@
         </p:nvSpPr>
         <p:spPr>
           <a:xfrm>
-            <a:off x="685800" y="2258568"/>
-            <a:ext cx="3456432" cy="731520"/>
+            <a:off x="685800" y="2185416"/>
+            <a:ext cx="5303520" cy="1078992"/>
           </a:xfrm>
           <a:prstGeom prst="roundRect">
             <a:avLst>
@@ -3804,8 +3809,8 @@
         </p:nvSpPr>
         <p:spPr>
           <a:xfrm>
-            <a:off x="832104" y="2368296"/>
-            <a:ext cx="3154680" cy="274320"/>
+            <a:off x="850392" y="2295144"/>
+            <a:ext cx="4974336" cy="274320"/>
           </a:xfrm>
           <a:prstGeom prst="rect">
             <a:avLst/>
@@ -3831,7 +3836,7 @@
               </a:defRPr>
             </a:pPr>
             <a:r>
-              <a:t>B｜严格转弯 ×2</a:t>
+              <a:t>原来：仅按目标距离加权</a:t>
             </a:r>
           </a:p>
         </p:txBody>
@@ -3844,8 +3849,8 @@
         </p:nvSpPr>
         <p:spPr>
           <a:xfrm>
-            <a:off x="832104" y="2743200"/>
-            <a:ext cx="3154680" cy="210312"/>
+            <a:off x="1051560" y="2761488"/>
+            <a:ext cx="1078992" cy="301752"/>
           </a:xfrm>
           <a:prstGeom prst="rect">
             <a:avLst/>
@@ -3863,93 +3868,7 @@
               <a:spcAft>
                 <a:spcPts val="700"/>
               </a:spcAft>
-              <a:defRPr sz="1000" b="0">
-                <a:solidFill>
-                  <a:srgbClr val="62748A"/>
-                </a:solidFill>
-                <a:latin typeface="Noto Sans CJK SC"/>
-              </a:defRPr>
-            </a:pPr>
-            <a:r>
-              <a:t>转弯样本损失权重加倍</a:t>
-            </a:r>
-          </a:p>
-        </p:txBody>
-      </p:sp>
-      <p:sp>
-        <p:nvSpPr>
-          <p:cNvPr id="10" name="Rounded Rectangle 9"/>
-          <p:cNvSpPr/>
-          <p:nvPr/>
-        </p:nvSpPr>
-        <p:spPr>
-          <a:xfrm>
-            <a:off x="4370832" y="2258568"/>
-            <a:ext cx="3456432" cy="731520"/>
-          </a:xfrm>
-          <a:prstGeom prst="roundRect">
-            <a:avLst>
-              <a:gd name="adj" fmla="val 12000"/>
-            </a:avLst>
-          </a:prstGeom>
-          <a:solidFill>
-            <a:srgbClr val="ECF1F7"/>
-          </a:solidFill>
-          <a:ln>
-            <a:noFill/>
-          </a:ln>
-          <a:effectLst/>
-        </p:spPr>
-        <p:style>
-          <a:lnRef idx="1">
-            <a:schemeClr val="accent1"/>
-          </a:lnRef>
-          <a:fillRef idx="3">
-            <a:schemeClr val="accent1"/>
-          </a:fillRef>
-          <a:effectRef idx="0">
-            <a:schemeClr val="accent1"/>
-          </a:effectRef>
-          <a:fontRef idx="minor">
-            <a:schemeClr val="lt1"/>
-          </a:fontRef>
-        </p:style>
-        <p:txBody>
-          <a:bodyPr rtlCol="0" anchor="ctr"/>
-          <a:lstStyle/>
-          <a:p>
-            <a:pPr algn="ctr"/>
-          </a:p>
-        </p:txBody>
-      </p:sp>
-      <p:sp>
-        <p:nvSpPr>
-          <p:cNvPr id="11" name="TextBox 10"/>
-          <p:cNvSpPr txBox="1"/>
-          <p:nvPr/>
-        </p:nvSpPr>
-        <p:spPr>
-          <a:xfrm>
-            <a:off x="4517136" y="2368296"/>
-            <a:ext cx="3154680" cy="274320"/>
-          </a:xfrm>
-          <a:prstGeom prst="rect">
-            <a:avLst/>
-          </a:prstGeom>
-          <a:noFill/>
-          <a:effectLst/>
-        </p:spPr>
-        <p:txBody>
-          <a:bodyPr wrap="none" lIns="0" rIns="0" tIns="0" bIns="0">
-            <a:spAutoFit/>
-          </a:bodyPr>
-          <a:lstStyle/>
-          <a:p>
-            <a:pPr>
-              <a:spcAft>
-                <a:spcPts val="700"/>
-              </a:spcAft>
-              <a:defRPr sz="1500" b="1">
+              <a:defRPr sz="1900" b="1">
                 <a:solidFill>
                   <a:srgbClr val="142B46"/>
                 </a:solidFill>
@@ -3957,21 +3876,21 @@
               </a:defRPr>
             </a:pPr>
             <a:r>
-              <a:t>C｜严格转弯 ×3</a:t>
-            </a:r>
-          </a:p>
-        </p:txBody>
-      </p:sp>
-      <p:sp>
-        <p:nvSpPr>
-          <p:cNvPr id="12" name="TextBox 11"/>
+              <a:t>L原 =</a:t>
+            </a:r>
+          </a:p>
+        </p:txBody>
+      </p:sp>
+      <p:sp>
+        <p:nvSpPr>
+          <p:cNvPr id="10" name="TextBox 9"/>
           <p:cNvSpPr txBox="1"/>
           <p:nvPr/>
         </p:nvSpPr>
         <p:spPr>
           <a:xfrm>
-            <a:off x="4517136" y="2743200"/>
-            <a:ext cx="3154680" cy="210312"/>
+            <a:off x="2304288" y="2651760"/>
+            <a:ext cx="2962656" cy="265176"/>
           </a:xfrm>
           <a:prstGeom prst="rect">
             <a:avLst/>
@@ -3985,97 +3904,11 @@
           </a:bodyPr>
           <a:lstStyle/>
           <a:p>
-            <a:pPr>
+            <a:pPr algn="ctr">
               <a:spcAft>
                 <a:spcPts val="700"/>
               </a:spcAft>
-              <a:defRPr sz="1000" b="0">
-                <a:solidFill>
-                  <a:srgbClr val="62748A"/>
-                </a:solidFill>
-                <a:latin typeface="Noto Sans CJK SC"/>
-              </a:defRPr>
-            </a:pPr>
-            <a:r>
-              <a:t>进一步提高转弯样本权重</a:t>
-            </a:r>
-          </a:p>
-        </p:txBody>
-      </p:sp>
-      <p:sp>
-        <p:nvSpPr>
-          <p:cNvPr id="13" name="Rounded Rectangle 12"/>
-          <p:cNvSpPr/>
-          <p:nvPr/>
-        </p:nvSpPr>
-        <p:spPr>
-          <a:xfrm>
-            <a:off x="8055864" y="2258568"/>
-            <a:ext cx="3456432" cy="731520"/>
-          </a:xfrm>
-          <a:prstGeom prst="roundRect">
-            <a:avLst>
-              <a:gd name="adj" fmla="val 12000"/>
-            </a:avLst>
-          </a:prstGeom>
-          <a:solidFill>
-            <a:srgbClr val="ECF1F7"/>
-          </a:solidFill>
-          <a:ln>
-            <a:noFill/>
-          </a:ln>
-          <a:effectLst/>
-        </p:spPr>
-        <p:style>
-          <a:lnRef idx="1">
-            <a:schemeClr val="accent1"/>
-          </a:lnRef>
-          <a:fillRef idx="3">
-            <a:schemeClr val="accent1"/>
-          </a:fillRef>
-          <a:effectRef idx="0">
-            <a:schemeClr val="accent1"/>
-          </a:effectRef>
-          <a:fontRef idx="minor">
-            <a:schemeClr val="lt1"/>
-          </a:fontRef>
-        </p:style>
-        <p:txBody>
-          <a:bodyPr rtlCol="0" anchor="ctr"/>
-          <a:lstStyle/>
-          <a:p>
-            <a:pPr algn="ctr"/>
-          </a:p>
-        </p:txBody>
-      </p:sp>
-      <p:sp>
-        <p:nvSpPr>
-          <p:cNvPr id="14" name="TextBox 13"/>
-          <p:cNvSpPr txBox="1"/>
-          <p:nvPr/>
-        </p:nvSpPr>
-        <p:spPr>
-          <a:xfrm>
-            <a:off x="8202168" y="2368296"/>
-            <a:ext cx="3154680" cy="274320"/>
-          </a:xfrm>
-          <a:prstGeom prst="rect">
-            <a:avLst/>
-          </a:prstGeom>
-          <a:noFill/>
-          <a:effectLst/>
-        </p:spPr>
-        <p:txBody>
-          <a:bodyPr wrap="none" lIns="0" rIns="0" tIns="0" bIns="0">
-            <a:spAutoFit/>
-          </a:bodyPr>
-          <a:lstStyle/>
-          <a:p>
-            <a:pPr>
-              <a:spcAft>
-                <a:spcPts val="700"/>
-              </a:spcAft>
-              <a:defRPr sz="1500" b="1">
+              <a:defRPr sz="1900" b="0">
                 <a:solidFill>
                   <a:srgbClr val="142B46"/>
                 </a:solidFill>
@@ -4083,800 +3916,28 @@
               </a:defRPr>
             </a:pPr>
             <a:r>
-              <a:t>D｜曲率分档</a:t>
-            </a:r>
-          </a:p>
-        </p:txBody>
-      </p:sp>
-      <p:sp>
-        <p:nvSpPr>
-          <p:cNvPr id="15" name="TextBox 14"/>
-          <p:cNvSpPr txBox="1"/>
-          <p:nvPr/>
-        </p:nvSpPr>
-        <p:spPr>
-          <a:xfrm>
-            <a:off x="8202168" y="2743200"/>
-            <a:ext cx="3154680" cy="210312"/>
-          </a:xfrm>
-          <a:prstGeom prst="rect">
-            <a:avLst/>
-          </a:prstGeom>
-          <a:noFill/>
-          <a:effectLst/>
-        </p:spPr>
-        <p:txBody>
-          <a:bodyPr wrap="none" lIns="0" rIns="0" tIns="0" bIns="0">
-            <a:spAutoFit/>
-          </a:bodyPr>
-          <a:lstStyle/>
-          <a:p>
-            <a:pPr>
-              <a:spcAft>
-                <a:spcPts val="700"/>
-              </a:spcAft>
-              <a:defRPr sz="1000" b="0">
-                <a:solidFill>
-                  <a:srgbClr val="62748A"/>
-                </a:solidFill>
-                <a:latin typeface="Noto Sans CJK SC"/>
-              </a:defRPr>
-            </a:pPr>
-            <a:r>
-              <a:t>累计转角三分位：权重 1 / 1.5 / 3</a:t>
-            </a:r>
-          </a:p>
-        </p:txBody>
-      </p:sp>
-      <p:sp>
-        <p:nvSpPr>
-          <p:cNvPr id="16" name="TextBox 15"/>
-          <p:cNvSpPr txBox="1"/>
-          <p:nvPr/>
-        </p:nvSpPr>
-        <p:spPr>
-          <a:xfrm>
-            <a:off x="685800" y="3236976"/>
-            <a:ext cx="9144000" cy="274320"/>
-          </a:xfrm>
-          <a:prstGeom prst="rect">
-            <a:avLst/>
-          </a:prstGeom>
-          <a:noFill/>
-          <a:effectLst/>
-        </p:spPr>
-        <p:txBody>
-          <a:bodyPr wrap="none" lIns="0" rIns="0" tIns="0" bIns="0">
-            <a:spAutoFit/>
-          </a:bodyPr>
-          <a:lstStyle/>
-          <a:p>
-            <a:pPr>
-              <a:spcAft>
-                <a:spcPts val="700"/>
-              </a:spcAft>
-              <a:defRPr sz="1600" b="1">
-                <a:solidFill>
-                  <a:srgbClr val="142B46"/>
-                </a:solidFill>
-                <a:latin typeface="Noto Sans CJK SC"/>
-              </a:defRPr>
-            </a:pPr>
-            <a:r>
-              <a:t>验证集对比：中位数改善，与尾部改善并不一致</a:t>
-            </a:r>
-          </a:p>
-        </p:txBody>
-      </p:sp>
-      <p:sp>
-        <p:nvSpPr>
-          <p:cNvPr id="17" name="Rounded Rectangle 16"/>
-          <p:cNvSpPr/>
-          <p:nvPr/>
-        </p:nvSpPr>
-        <p:spPr>
-          <a:xfrm>
-            <a:off x="685800" y="3602736"/>
-            <a:ext cx="10826496" cy="438912"/>
-          </a:xfrm>
-          <a:prstGeom prst="roundRect">
-            <a:avLst>
-              <a:gd name="adj" fmla="val 12000"/>
-            </a:avLst>
-          </a:prstGeom>
-          <a:solidFill>
-            <a:srgbClr val="ECF1F7"/>
-          </a:solidFill>
-          <a:ln>
-            <a:noFill/>
-          </a:ln>
-          <a:effectLst/>
-        </p:spPr>
-        <p:style>
-          <a:lnRef idx="1">
-            <a:schemeClr val="accent1"/>
-          </a:lnRef>
-          <a:fillRef idx="3">
-            <a:schemeClr val="accent1"/>
-          </a:fillRef>
-          <a:effectRef idx="0">
-            <a:schemeClr val="accent1"/>
-          </a:effectRef>
-          <a:fontRef idx="minor">
-            <a:schemeClr val="lt1"/>
-          </a:fontRef>
-        </p:style>
-        <p:txBody>
-          <a:bodyPr rtlCol="0" anchor="ctr"/>
-          <a:lstStyle/>
-          <a:p>
-            <a:pPr algn="ctr"/>
-          </a:p>
-        </p:txBody>
-      </p:sp>
-      <p:sp>
-        <p:nvSpPr>
-          <p:cNvPr id="18" name="TextBox 17"/>
-          <p:cNvSpPr txBox="1"/>
-          <p:nvPr/>
-        </p:nvSpPr>
-        <p:spPr>
-          <a:xfrm>
-            <a:off x="841248" y="3721608"/>
-            <a:ext cx="2834640" cy="237744"/>
-          </a:xfrm>
-          <a:prstGeom prst="rect">
-            <a:avLst/>
-          </a:prstGeom>
-          <a:noFill/>
-          <a:effectLst/>
-        </p:spPr>
-        <p:txBody>
-          <a:bodyPr wrap="none" lIns="0" rIns="0" tIns="0" bIns="0">
-            <a:spAutoFit/>
-          </a:bodyPr>
-          <a:lstStyle/>
-          <a:p>
-            <a:pPr>
-              <a:spcAft>
-                <a:spcPts val="700"/>
-              </a:spcAft>
-              <a:defRPr sz="1200" b="1">
-                <a:solidFill>
-                  <a:srgbClr val="62748A"/>
-                </a:solidFill>
-                <a:latin typeface="Noto Sans CJK SC"/>
-              </a:defRPr>
-            </a:pPr>
-            <a:r>
-              <a:t>WP 训练方案</a:t>
-            </a:r>
-          </a:p>
-        </p:txBody>
-      </p:sp>
-      <p:sp>
-        <p:nvSpPr>
-          <p:cNvPr id="19" name="TextBox 18"/>
-          <p:cNvSpPr txBox="1"/>
-          <p:nvPr/>
-        </p:nvSpPr>
-        <p:spPr>
-          <a:xfrm>
-            <a:off x="4005072" y="3721608"/>
-            <a:ext cx="1773936" cy="228600"/>
-          </a:xfrm>
-          <a:prstGeom prst="rect">
-            <a:avLst/>
-          </a:prstGeom>
-          <a:noFill/>
-          <a:effectLst/>
-        </p:spPr>
-        <p:txBody>
-          <a:bodyPr wrap="none" lIns="0" rIns="0" tIns="0" bIns="0">
-            <a:spAutoFit/>
-          </a:bodyPr>
-          <a:lstStyle/>
-          <a:p>
-            <a:pPr algn="ctr">
-              <a:spcAft>
-                <a:spcPts val="700"/>
-              </a:spcAft>
-              <a:defRPr sz="1100" b="1">
-                <a:solidFill>
-                  <a:srgbClr val="62748A"/>
-                </a:solidFill>
-                <a:latin typeface="Noto Sans CJK SC"/>
-              </a:defRPr>
-            </a:pPr>
-            <a:r>
-              <a:t>全量中位误差 ↓</a:t>
-            </a:r>
-          </a:p>
-        </p:txBody>
-      </p:sp>
-      <p:sp>
-        <p:nvSpPr>
-          <p:cNvPr id="20" name="TextBox 19"/>
-          <p:cNvSpPr txBox="1"/>
-          <p:nvPr/>
-        </p:nvSpPr>
-        <p:spPr>
-          <a:xfrm>
-            <a:off x="5870448" y="3721608"/>
-            <a:ext cx="1773936" cy="228600"/>
-          </a:xfrm>
-          <a:prstGeom prst="rect">
-            <a:avLst/>
-          </a:prstGeom>
-          <a:noFill/>
-          <a:effectLst/>
-        </p:spPr>
-        <p:txBody>
-          <a:bodyPr wrap="none" lIns="0" rIns="0" tIns="0" bIns="0">
-            <a:spAutoFit/>
-          </a:bodyPr>
-          <a:lstStyle/>
-          <a:p>
-            <a:pPr algn="ctr">
-              <a:spcAft>
-                <a:spcPts val="700"/>
-              </a:spcAft>
-              <a:defRPr sz="1100" b="1">
-                <a:solidFill>
-                  <a:srgbClr val="62748A"/>
-                </a:solidFill>
-                <a:latin typeface="Noto Sans CJK SC"/>
-              </a:defRPr>
-            </a:pPr>
-            <a:r>
-              <a:t>转弯中位误差 ↓</a:t>
-            </a:r>
-          </a:p>
-        </p:txBody>
-      </p:sp>
-      <p:sp>
-        <p:nvSpPr>
-          <p:cNvPr id="21" name="TextBox 20"/>
-          <p:cNvSpPr txBox="1"/>
-          <p:nvPr/>
-        </p:nvSpPr>
-        <p:spPr>
-          <a:xfrm>
-            <a:off x="7735824" y="3721608"/>
-            <a:ext cx="1773936" cy="228600"/>
-          </a:xfrm>
-          <a:prstGeom prst="rect">
-            <a:avLst/>
-          </a:prstGeom>
-          <a:noFill/>
-          <a:effectLst/>
-        </p:spPr>
-        <p:txBody>
-          <a:bodyPr wrap="none" lIns="0" rIns="0" tIns="0" bIns="0">
-            <a:spAutoFit/>
-          </a:bodyPr>
-          <a:lstStyle/>
-          <a:p>
-            <a:pPr algn="ctr">
-              <a:spcAft>
-                <a:spcPts val="700"/>
-              </a:spcAft>
-              <a:defRPr sz="1100" b="1">
-                <a:solidFill>
-                  <a:srgbClr val="62748A"/>
-                </a:solidFill>
-                <a:latin typeface="Noto Sans CJK SC"/>
-              </a:defRPr>
-            </a:pPr>
-            <a:r>
-              <a:t>转弯 P90 ↓</a:t>
-            </a:r>
-          </a:p>
-        </p:txBody>
-      </p:sp>
-      <p:sp>
-        <p:nvSpPr>
-          <p:cNvPr id="22" name="TextBox 21"/>
-          <p:cNvSpPr txBox="1"/>
-          <p:nvPr/>
-        </p:nvSpPr>
-        <p:spPr>
-          <a:xfrm>
-            <a:off x="9601200" y="3721608"/>
-            <a:ext cx="1911095" cy="228600"/>
-          </a:xfrm>
-          <a:prstGeom prst="rect">
-            <a:avLst/>
-          </a:prstGeom>
-          <a:noFill/>
-          <a:effectLst/>
-        </p:spPr>
-        <p:txBody>
-          <a:bodyPr wrap="none" lIns="0" rIns="0" tIns="0" bIns="0">
-            <a:spAutoFit/>
-          </a:bodyPr>
-          <a:lstStyle/>
-          <a:p>
-            <a:pPr algn="ctr">
-              <a:spcAft>
-                <a:spcPts val="700"/>
-              </a:spcAft>
-              <a:defRPr sz="1100" b="1">
-                <a:solidFill>
-                  <a:srgbClr val="62748A"/>
-                </a:solidFill>
-                <a:latin typeface="Noto Sans CJK SC"/>
-              </a:defRPr>
-            </a:pPr>
-            <a:r>
-              <a:t>全量 &gt;45° 占比 ↓</a:t>
-            </a:r>
-          </a:p>
-        </p:txBody>
-      </p:sp>
-      <p:sp>
-        <p:nvSpPr>
-          <p:cNvPr id="23" name="Rounded Rectangle 22"/>
-          <p:cNvSpPr/>
-          <p:nvPr/>
-        </p:nvSpPr>
-        <p:spPr>
-          <a:xfrm>
-            <a:off x="685800" y="4105656"/>
-            <a:ext cx="10826496" cy="374904"/>
-          </a:xfrm>
-          <a:prstGeom prst="roundRect">
-            <a:avLst>
-              <a:gd name="adj" fmla="val 12000"/>
-            </a:avLst>
-          </a:prstGeom>
-          <a:solidFill>
-            <a:srgbClr val="E8F4F2"/>
-          </a:solidFill>
-          <a:ln>
-            <a:noFill/>
-          </a:ln>
-          <a:effectLst/>
-        </p:spPr>
-        <p:style>
-          <a:lnRef idx="1">
-            <a:schemeClr val="accent1"/>
-          </a:lnRef>
-          <a:fillRef idx="3">
-            <a:schemeClr val="accent1"/>
-          </a:fillRef>
-          <a:effectRef idx="0">
-            <a:schemeClr val="accent1"/>
-          </a:effectRef>
-          <a:fontRef idx="minor">
-            <a:schemeClr val="lt1"/>
-          </a:fontRef>
-        </p:style>
-        <p:txBody>
-          <a:bodyPr rtlCol="0" anchor="ctr"/>
-          <a:lstStyle/>
-          <a:p>
-            <a:pPr algn="ctr"/>
-          </a:p>
-        </p:txBody>
-      </p:sp>
-      <p:sp>
-        <p:nvSpPr>
-          <p:cNvPr id="24" name="TextBox 23"/>
-          <p:cNvSpPr txBox="1"/>
-          <p:nvPr/>
-        </p:nvSpPr>
-        <p:spPr>
-          <a:xfrm>
-            <a:off x="841248" y="4123944"/>
-            <a:ext cx="3108960" cy="274320"/>
-          </a:xfrm>
-          <a:prstGeom prst="rect">
-            <a:avLst/>
-          </a:prstGeom>
-          <a:noFill/>
-          <a:effectLst/>
-        </p:spPr>
-        <p:txBody>
-          <a:bodyPr wrap="none" lIns="0" rIns="0" tIns="0" bIns="0">
-            <a:spAutoFit/>
-          </a:bodyPr>
-          <a:lstStyle/>
-          <a:p>
-            <a:pPr>
-              <a:spcAft>
-                <a:spcPts val="700"/>
-              </a:spcAft>
-              <a:defRPr sz="1200" b="1">
-                <a:solidFill>
-                  <a:srgbClr val="142B46"/>
-                </a:solidFill>
-                <a:latin typeface="Noto Sans CJK SC"/>
-              </a:defRPr>
-            </a:pPr>
-            <a:r>
-              <a:t>ctx2｜无额外加权（参考）</a:t>
-            </a:r>
-          </a:p>
-        </p:txBody>
-      </p:sp>
-      <p:sp>
-        <p:nvSpPr>
-          <p:cNvPr id="25" name="TextBox 24"/>
-          <p:cNvSpPr txBox="1"/>
-          <p:nvPr/>
-        </p:nvSpPr>
-        <p:spPr>
-          <a:xfrm>
-            <a:off x="4005072" y="4123944"/>
-            <a:ext cx="1773936" cy="283464"/>
-          </a:xfrm>
-          <a:prstGeom prst="rect">
-            <a:avLst/>
-          </a:prstGeom>
-          <a:noFill/>
-          <a:effectLst/>
-        </p:spPr>
-        <p:txBody>
-          <a:bodyPr wrap="none" lIns="0" rIns="0" tIns="0" bIns="0">
-            <a:spAutoFit/>
-          </a:bodyPr>
-          <a:lstStyle/>
-          <a:p>
-            <a:pPr algn="ctr">
-              <a:spcAft>
-                <a:spcPts val="700"/>
-              </a:spcAft>
-              <a:defRPr sz="1400" b="1">
-                <a:solidFill>
-                  <a:srgbClr val="148D91"/>
-                </a:solidFill>
-                <a:latin typeface="Noto Sans CJK SC"/>
-              </a:defRPr>
-            </a:pPr>
-            <a:r>
-              <a:t>7.97°</a:t>
-            </a:r>
-          </a:p>
-        </p:txBody>
-      </p:sp>
-      <p:sp>
-        <p:nvSpPr>
-          <p:cNvPr id="26" name="TextBox 25"/>
-          <p:cNvSpPr txBox="1"/>
-          <p:nvPr/>
-        </p:nvSpPr>
-        <p:spPr>
-          <a:xfrm>
-            <a:off x="5870448" y="4123944"/>
-            <a:ext cx="1773936" cy="283464"/>
-          </a:xfrm>
-          <a:prstGeom prst="rect">
-            <a:avLst/>
-          </a:prstGeom>
-          <a:noFill/>
-          <a:effectLst/>
-        </p:spPr>
-        <p:txBody>
-          <a:bodyPr wrap="none" lIns="0" rIns="0" tIns="0" bIns="0">
-            <a:spAutoFit/>
-          </a:bodyPr>
-          <a:lstStyle/>
-          <a:p>
-            <a:pPr algn="ctr">
-              <a:spcAft>
-                <a:spcPts val="700"/>
-              </a:spcAft>
-              <a:defRPr sz="1400" b="1">
-                <a:solidFill>
-                  <a:srgbClr val="142B46"/>
-                </a:solidFill>
-                <a:latin typeface="Noto Sans CJK SC"/>
-              </a:defRPr>
-            </a:pPr>
-            <a:r>
-              <a:t>13.02°</a:t>
-            </a:r>
-          </a:p>
-        </p:txBody>
-      </p:sp>
-      <p:sp>
-        <p:nvSpPr>
-          <p:cNvPr id="27" name="TextBox 26"/>
-          <p:cNvSpPr txBox="1"/>
-          <p:nvPr/>
-        </p:nvSpPr>
-        <p:spPr>
-          <a:xfrm>
-            <a:off x="7735824" y="4123944"/>
-            <a:ext cx="1773936" cy="283464"/>
-          </a:xfrm>
-          <a:prstGeom prst="rect">
-            <a:avLst/>
-          </a:prstGeom>
-          <a:noFill/>
-          <a:effectLst/>
-        </p:spPr>
-        <p:txBody>
-          <a:bodyPr wrap="none" lIns="0" rIns="0" tIns="0" bIns="0">
-            <a:spAutoFit/>
-          </a:bodyPr>
-          <a:lstStyle/>
-          <a:p>
-            <a:pPr algn="ctr">
-              <a:spcAft>
-                <a:spcPts val="700"/>
-              </a:spcAft>
-              <a:defRPr sz="1400" b="1">
-                <a:solidFill>
-                  <a:srgbClr val="148D91"/>
-                </a:solidFill>
-                <a:latin typeface="Noto Sans CJK SC"/>
-              </a:defRPr>
-            </a:pPr>
-            <a:r>
-              <a:t>53.12°</a:t>
-            </a:r>
-          </a:p>
-        </p:txBody>
-      </p:sp>
-      <p:sp>
-        <p:nvSpPr>
-          <p:cNvPr id="28" name="TextBox 27"/>
-          <p:cNvSpPr txBox="1"/>
-          <p:nvPr/>
-        </p:nvSpPr>
-        <p:spPr>
-          <a:xfrm>
-            <a:off x="9601200" y="4123944"/>
-            <a:ext cx="1911095" cy="283464"/>
-          </a:xfrm>
-          <a:prstGeom prst="rect">
-            <a:avLst/>
-          </a:prstGeom>
-          <a:noFill/>
-          <a:effectLst/>
-        </p:spPr>
-        <p:txBody>
-          <a:bodyPr wrap="none" lIns="0" rIns="0" tIns="0" bIns="0">
-            <a:spAutoFit/>
-          </a:bodyPr>
-          <a:lstStyle/>
-          <a:p>
-            <a:pPr algn="ctr">
-              <a:spcAft>
-                <a:spcPts val="700"/>
-              </a:spcAft>
-              <a:defRPr sz="1400" b="1">
-                <a:solidFill>
-                  <a:srgbClr val="148D91"/>
-                </a:solidFill>
-                <a:latin typeface="Noto Sans CJK SC"/>
-              </a:defRPr>
-            </a:pPr>
-            <a:r>
-              <a:t>7.08%</a:t>
-            </a:r>
-          </a:p>
-        </p:txBody>
-      </p:sp>
-      <p:sp>
-        <p:nvSpPr>
-          <p:cNvPr id="29" name="TextBox 28"/>
-          <p:cNvSpPr txBox="1"/>
-          <p:nvPr/>
-        </p:nvSpPr>
-        <p:spPr>
-          <a:xfrm>
-            <a:off x="841248" y="4517136"/>
-            <a:ext cx="3108960" cy="274320"/>
-          </a:xfrm>
-          <a:prstGeom prst="rect">
-            <a:avLst/>
-          </a:prstGeom>
-          <a:noFill/>
-          <a:effectLst/>
-        </p:spPr>
-        <p:txBody>
-          <a:bodyPr wrap="none" lIns="0" rIns="0" tIns="0" bIns="0">
-            <a:spAutoFit/>
-          </a:bodyPr>
-          <a:lstStyle/>
-          <a:p>
-            <a:pPr>
-              <a:spcAft>
-                <a:spcPts val="700"/>
-              </a:spcAft>
-              <a:defRPr sz="1200" b="0">
-                <a:solidFill>
-                  <a:srgbClr val="142B46"/>
-                </a:solidFill>
-                <a:latin typeface="Noto Sans CJK SC"/>
-              </a:defRPr>
-            </a:pPr>
-            <a:r>
-              <a:t>B｜严格转弯 ×2</a:t>
-            </a:r>
-          </a:p>
-        </p:txBody>
-      </p:sp>
-      <p:sp>
-        <p:nvSpPr>
-          <p:cNvPr id="30" name="TextBox 29"/>
-          <p:cNvSpPr txBox="1"/>
-          <p:nvPr/>
-        </p:nvSpPr>
-        <p:spPr>
-          <a:xfrm>
-            <a:off x="4005072" y="4517136"/>
-            <a:ext cx="1773936" cy="283464"/>
-          </a:xfrm>
-          <a:prstGeom prst="rect">
-            <a:avLst/>
-          </a:prstGeom>
-          <a:noFill/>
-          <a:effectLst/>
-        </p:spPr>
-        <p:txBody>
-          <a:bodyPr wrap="none" lIns="0" rIns="0" tIns="0" bIns="0">
-            <a:spAutoFit/>
-          </a:bodyPr>
-          <a:lstStyle/>
-          <a:p>
-            <a:pPr algn="ctr">
-              <a:spcAft>
-                <a:spcPts val="700"/>
-              </a:spcAft>
-              <a:defRPr sz="1400" b="0">
-                <a:solidFill>
-                  <a:srgbClr val="142B46"/>
-                </a:solidFill>
-                <a:latin typeface="Noto Sans CJK SC"/>
-              </a:defRPr>
-            </a:pPr>
-            <a:r>
-              <a:t>8.04°</a:t>
-            </a:r>
-          </a:p>
-        </p:txBody>
-      </p:sp>
-      <p:sp>
-        <p:nvSpPr>
-          <p:cNvPr id="31" name="TextBox 30"/>
-          <p:cNvSpPr txBox="1"/>
-          <p:nvPr/>
-        </p:nvSpPr>
-        <p:spPr>
-          <a:xfrm>
-            <a:off x="5870448" y="4517136"/>
-            <a:ext cx="1773936" cy="283464"/>
-          </a:xfrm>
-          <a:prstGeom prst="rect">
-            <a:avLst/>
-          </a:prstGeom>
-          <a:noFill/>
-          <a:effectLst/>
-        </p:spPr>
-        <p:txBody>
-          <a:bodyPr wrap="none" lIns="0" rIns="0" tIns="0" bIns="0">
-            <a:spAutoFit/>
-          </a:bodyPr>
-          <a:lstStyle/>
-          <a:p>
-            <a:pPr algn="ctr">
-              <a:spcAft>
-                <a:spcPts val="700"/>
-              </a:spcAft>
-              <a:defRPr sz="1400" b="1">
-                <a:solidFill>
-                  <a:srgbClr val="148D91"/>
-                </a:solidFill>
-                <a:latin typeface="Noto Sans CJK SC"/>
-              </a:defRPr>
-            </a:pPr>
-            <a:r>
-              <a:t>12.11°</a:t>
-            </a:r>
-          </a:p>
-        </p:txBody>
-      </p:sp>
-      <p:sp>
-        <p:nvSpPr>
-          <p:cNvPr id="32" name="TextBox 31"/>
-          <p:cNvSpPr txBox="1"/>
-          <p:nvPr/>
-        </p:nvSpPr>
-        <p:spPr>
-          <a:xfrm>
-            <a:off x="7735824" y="4517136"/>
-            <a:ext cx="1773936" cy="283464"/>
-          </a:xfrm>
-          <a:prstGeom prst="rect">
-            <a:avLst/>
-          </a:prstGeom>
-          <a:noFill/>
-          <a:effectLst/>
-        </p:spPr>
-        <p:txBody>
-          <a:bodyPr wrap="none" lIns="0" rIns="0" tIns="0" bIns="0">
-            <a:spAutoFit/>
-          </a:bodyPr>
-          <a:lstStyle/>
-          <a:p>
-            <a:pPr algn="ctr">
-              <a:spcAft>
-                <a:spcPts val="700"/>
-              </a:spcAft>
-              <a:defRPr sz="1400" b="0">
-                <a:solidFill>
-                  <a:srgbClr val="142B46"/>
-                </a:solidFill>
-                <a:latin typeface="Noto Sans CJK SC"/>
-              </a:defRPr>
-            </a:pPr>
-            <a:r>
-              <a:t>55.77°</a:t>
-            </a:r>
-          </a:p>
-        </p:txBody>
-      </p:sp>
-      <p:sp>
-        <p:nvSpPr>
-          <p:cNvPr id="33" name="TextBox 32"/>
-          <p:cNvSpPr txBox="1"/>
-          <p:nvPr/>
-        </p:nvSpPr>
-        <p:spPr>
-          <a:xfrm>
-            <a:off x="9601200" y="4517136"/>
-            <a:ext cx="1911095" cy="283464"/>
-          </a:xfrm>
-          <a:prstGeom prst="rect">
-            <a:avLst/>
-          </a:prstGeom>
-          <a:noFill/>
-          <a:effectLst/>
-        </p:spPr>
-        <p:txBody>
-          <a:bodyPr wrap="none" lIns="0" rIns="0" tIns="0" bIns="0">
-            <a:spAutoFit/>
-          </a:bodyPr>
-          <a:lstStyle/>
-          <a:p>
-            <a:pPr algn="ctr">
-              <a:spcAft>
-                <a:spcPts val="700"/>
-              </a:spcAft>
-              <a:defRPr sz="1400" b="0">
-                <a:solidFill>
-                  <a:srgbClr val="142B46"/>
-                </a:solidFill>
-                <a:latin typeface="Noto Sans CJK SC"/>
-              </a:defRPr>
-            </a:pPr>
-            <a:r>
-              <a:t>8.04%</a:t>
+              <a:t>∑ᵢ bᵢ ℓᵢ</a:t>
             </a:r>
           </a:p>
         </p:txBody>
       </p:sp>
       <p:cxnSp>
         <p:nvCxnSpPr>
-          <p:cNvPr id="34" name="Connector 33"/>
+          <p:cNvPr id="11" name="Connector 10"/>
           <p:cNvCxnSpPr/>
           <p:nvPr/>
         </p:nvCxnSpPr>
         <p:spPr>
           <a:xfrm>
-            <a:off x="685800" y="4828031"/>
-            <a:ext cx="10826496" cy="0"/>
+            <a:off x="2304288" y="2926080"/>
+            <a:ext cx="2962656" cy="0"/>
           </a:xfrm>
           <a:prstGeom prst="line">
             <a:avLst/>
           </a:prstGeom>
-          <a:ln w="8255">
+          <a:ln w="13335">
             <a:solidFill>
-              <a:srgbClr val="DCE5EF"/>
+              <a:srgbClr val="142B46"/>
             </a:solidFill>
           </a:ln>
           <a:effectLst/>
@@ -4898,14 +3959,14 @@
       </p:cxnSp>
       <p:sp>
         <p:nvSpPr>
-          <p:cNvPr id="35" name="TextBox 34"/>
+          <p:cNvPr id="12" name="TextBox 11"/>
           <p:cNvSpPr txBox="1"/>
           <p:nvPr/>
         </p:nvSpPr>
         <p:spPr>
           <a:xfrm>
-            <a:off x="841248" y="4910328"/>
-            <a:ext cx="3108960" cy="274320"/>
+            <a:off x="2304288" y="2971800"/>
+            <a:ext cx="2962656" cy="265176"/>
           </a:xfrm>
           <a:prstGeom prst="rect">
             <a:avLst/>
@@ -4919,11 +3980,11 @@
           </a:bodyPr>
           <a:lstStyle/>
           <a:p>
-            <a:pPr>
+            <a:pPr algn="ctr">
               <a:spcAft>
                 <a:spcPts val="700"/>
               </a:spcAft>
-              <a:defRPr sz="1200" b="0">
+              <a:defRPr sz="1900" b="0">
                 <a:solidFill>
                   <a:srgbClr val="142B46"/>
                 </a:solidFill>
@@ -4931,21 +3992,67 @@
               </a:defRPr>
             </a:pPr>
             <a:r>
-              <a:t>C｜严格转弯 ×3</a:t>
-            </a:r>
-          </a:p>
-        </p:txBody>
-      </p:sp>
-      <p:sp>
-        <p:nvSpPr>
-          <p:cNvPr id="36" name="TextBox 35"/>
+              <a:t>∑ᵢ bᵢ</a:t>
+            </a:r>
+          </a:p>
+        </p:txBody>
+      </p:sp>
+      <p:sp>
+        <p:nvSpPr>
+          <p:cNvPr id="13" name="Rounded Rectangle 12"/>
+          <p:cNvSpPr/>
+          <p:nvPr/>
+        </p:nvSpPr>
+        <p:spPr>
+          <a:xfrm>
+            <a:off x="6208776" y="2185416"/>
+            <a:ext cx="5303520" cy="1078992"/>
+          </a:xfrm>
+          <a:prstGeom prst="roundRect">
+            <a:avLst>
+              <a:gd name="adj" fmla="val 12000"/>
+            </a:avLst>
+          </a:prstGeom>
+          <a:solidFill>
+            <a:srgbClr val="E8F4F2"/>
+          </a:solidFill>
+          <a:ln>
+            <a:noFill/>
+          </a:ln>
+          <a:effectLst/>
+        </p:spPr>
+        <p:style>
+          <a:lnRef idx="1">
+            <a:schemeClr val="accent1"/>
+          </a:lnRef>
+          <a:fillRef idx="3">
+            <a:schemeClr val="accent1"/>
+          </a:fillRef>
+          <a:effectRef idx="0">
+            <a:schemeClr val="accent1"/>
+          </a:effectRef>
+          <a:fontRef idx="minor">
+            <a:schemeClr val="lt1"/>
+          </a:fontRef>
+        </p:style>
+        <p:txBody>
+          <a:bodyPr rtlCol="0" anchor="ctr"/>
+          <a:lstStyle/>
+          <a:p>
+            <a:pPr algn="ctr"/>
+          </a:p>
+        </p:txBody>
+      </p:sp>
+      <p:sp>
+        <p:nvSpPr>
+          <p:cNvPr id="14" name="TextBox 13"/>
           <p:cNvSpPr txBox="1"/>
           <p:nvPr/>
         </p:nvSpPr>
         <p:spPr>
           <a:xfrm>
-            <a:off x="4005072" y="4910328"/>
-            <a:ext cx="1773936" cy="283464"/>
+            <a:off x="6373368" y="2295144"/>
+            <a:ext cx="4974336" cy="274320"/>
           </a:xfrm>
           <a:prstGeom prst="rect">
             <a:avLst/>
@@ -4959,51 +4066,11 @@
           </a:bodyPr>
           <a:lstStyle/>
           <a:p>
-            <a:pPr algn="ctr">
+            <a:pPr>
               <a:spcAft>
                 <a:spcPts val="700"/>
               </a:spcAft>
-              <a:defRPr sz="1400" b="0">
-                <a:solidFill>
-                  <a:srgbClr val="142B46"/>
-                </a:solidFill>
-                <a:latin typeface="Noto Sans CJK SC"/>
-              </a:defRPr>
-            </a:pPr>
-            <a:r>
-              <a:t>8.11°</a:t>
-            </a:r>
-          </a:p>
-        </p:txBody>
-      </p:sp>
-      <p:sp>
-        <p:nvSpPr>
-          <p:cNvPr id="37" name="TextBox 36"/>
-          <p:cNvSpPr txBox="1"/>
-          <p:nvPr/>
-        </p:nvSpPr>
-        <p:spPr>
-          <a:xfrm>
-            <a:off x="5870448" y="4910328"/>
-            <a:ext cx="1773936" cy="283464"/>
-          </a:xfrm>
-          <a:prstGeom prst="rect">
-            <a:avLst/>
-          </a:prstGeom>
-          <a:noFill/>
-          <a:effectLst/>
-        </p:spPr>
-        <p:txBody>
-          <a:bodyPr wrap="none" lIns="0" rIns="0" tIns="0" bIns="0">
-            <a:spAutoFit/>
-          </a:bodyPr>
-          <a:lstStyle/>
-          <a:p>
-            <a:pPr algn="ctr">
-              <a:spcAft>
-                <a:spcPts val="700"/>
-              </a:spcAft>
-              <a:defRPr sz="1400" b="1">
+              <a:defRPr sz="1500" b="1">
                 <a:solidFill>
                   <a:srgbClr val="148D91"/>
                 </a:solidFill>
@@ -5011,21 +4078,61 @@
               </a:defRPr>
             </a:pPr>
             <a:r>
-              <a:t>12.55°</a:t>
-            </a:r>
-          </a:p>
-        </p:txBody>
-      </p:sp>
-      <p:sp>
-        <p:nvSpPr>
-          <p:cNvPr id="38" name="TextBox 37"/>
+              <a:t>现在：距离权重 × 转弯权重</a:t>
+            </a:r>
+          </a:p>
+        </p:txBody>
+      </p:sp>
+      <p:sp>
+        <p:nvSpPr>
+          <p:cNvPr id="15" name="TextBox 14"/>
           <p:cNvSpPr txBox="1"/>
           <p:nvPr/>
         </p:nvSpPr>
         <p:spPr>
           <a:xfrm>
-            <a:off x="7735824" y="4910328"/>
-            <a:ext cx="1773936" cy="283464"/>
+            <a:off x="6574536" y="2761488"/>
+            <a:ext cx="1078992" cy="301752"/>
+          </a:xfrm>
+          <a:prstGeom prst="rect">
+            <a:avLst/>
+          </a:prstGeom>
+          <a:noFill/>
+          <a:effectLst/>
+        </p:spPr>
+        <p:txBody>
+          <a:bodyPr wrap="none" lIns="0" rIns="0" tIns="0" bIns="0">
+            <a:spAutoFit/>
+          </a:bodyPr>
+          <a:lstStyle/>
+          <a:p>
+            <a:pPr>
+              <a:spcAft>
+                <a:spcPts val="700"/>
+              </a:spcAft>
+              <a:defRPr sz="1900" b="1">
+                <a:solidFill>
+                  <a:srgbClr val="148D91"/>
+                </a:solidFill>
+                <a:latin typeface="Noto Sans CJK SC"/>
+              </a:defRPr>
+            </a:pPr>
+            <a:r>
+              <a:t>L新 =</a:t>
+            </a:r>
+          </a:p>
+        </p:txBody>
+      </p:sp>
+      <p:sp>
+        <p:nvSpPr>
+          <p:cNvPr id="16" name="TextBox 15"/>
+          <p:cNvSpPr txBox="1"/>
+          <p:nvPr/>
+        </p:nvSpPr>
+        <p:spPr>
+          <a:xfrm>
+            <a:off x="7827264" y="2651760"/>
+            <a:ext cx="2962656" cy="265176"/>
           </a:xfrm>
           <a:prstGeom prst="rect">
             <a:avLst/>
@@ -5043,76 +4150,36 @@
               <a:spcAft>
                 <a:spcPts val="700"/>
               </a:spcAft>
-              <a:defRPr sz="1400" b="0">
+              <a:defRPr sz="1900" b="0">
                 <a:solidFill>
-                  <a:srgbClr val="142B46"/>
+                  <a:srgbClr val="148D91"/>
                 </a:solidFill>
                 <a:latin typeface="Noto Sans CJK SC"/>
               </a:defRPr>
             </a:pPr>
             <a:r>
-              <a:t>54.01°</a:t>
-            </a:r>
-          </a:p>
-        </p:txBody>
-      </p:sp>
-      <p:sp>
-        <p:nvSpPr>
-          <p:cNvPr id="39" name="TextBox 38"/>
-          <p:cNvSpPr txBox="1"/>
-          <p:nvPr/>
-        </p:nvSpPr>
-        <p:spPr>
-          <a:xfrm>
-            <a:off x="9601200" y="4910328"/>
-            <a:ext cx="1911095" cy="283464"/>
-          </a:xfrm>
-          <a:prstGeom prst="rect">
-            <a:avLst/>
-          </a:prstGeom>
-          <a:noFill/>
-          <a:effectLst/>
-        </p:spPr>
-        <p:txBody>
-          <a:bodyPr wrap="none" lIns="0" rIns="0" tIns="0" bIns="0">
-            <a:spAutoFit/>
-          </a:bodyPr>
-          <a:lstStyle/>
-          <a:p>
-            <a:pPr algn="ctr">
-              <a:spcAft>
-                <a:spcPts val="700"/>
-              </a:spcAft>
-              <a:defRPr sz="1400" b="0">
-                <a:solidFill>
-                  <a:srgbClr val="142B46"/>
-                </a:solidFill>
-                <a:latin typeface="Noto Sans CJK SC"/>
-              </a:defRPr>
-            </a:pPr>
-            <a:r>
-              <a:t>7.44%</a:t>
+              <a:t>∑ᵢ bᵢ αᵢ ℓᵢ</a:t>
             </a:r>
           </a:p>
         </p:txBody>
       </p:sp>
       <p:cxnSp>
         <p:nvCxnSpPr>
-          <p:cNvPr id="40" name="Connector 39"/>
+          <p:cNvPr id="17" name="Connector 16"/>
           <p:cNvCxnSpPr/>
           <p:nvPr/>
         </p:nvCxnSpPr>
         <p:spPr>
           <a:xfrm>
-            <a:off x="685800" y="5221224"/>
-            <a:ext cx="10826496" cy="0"/>
+            <a:off x="7827264" y="2926080"/>
+            <a:ext cx="2962656" cy="0"/>
           </a:xfrm>
           <a:prstGeom prst="line">
             <a:avLst/>
           </a:prstGeom>
-          <a:ln w="8255">
+          <a:ln w="13335">
             <a:solidFill>
-              <a:srgbClr val="DCE5EF"/>
+              <a:srgbClr val="148D91"/>
             </a:solidFill>
           </a:ln>
           <a:effectLst/>
@@ -5134,14 +4201,54 @@
       </p:cxnSp>
       <p:sp>
         <p:nvSpPr>
-          <p:cNvPr id="41" name="TextBox 40"/>
+          <p:cNvPr id="18" name="TextBox 17"/>
           <p:cNvSpPr txBox="1"/>
           <p:nvPr/>
         </p:nvSpPr>
         <p:spPr>
           <a:xfrm>
-            <a:off x="841248" y="5303520"/>
-            <a:ext cx="3108960" cy="274320"/>
+            <a:off x="7827264" y="2971800"/>
+            <a:ext cx="2962656" cy="265176"/>
+          </a:xfrm>
+          <a:prstGeom prst="rect">
+            <a:avLst/>
+          </a:prstGeom>
+          <a:noFill/>
+          <a:effectLst/>
+        </p:spPr>
+        <p:txBody>
+          <a:bodyPr wrap="none" lIns="0" rIns="0" tIns="0" bIns="0">
+            <a:spAutoFit/>
+          </a:bodyPr>
+          <a:lstStyle/>
+          <a:p>
+            <a:pPr algn="ctr">
+              <a:spcAft>
+                <a:spcPts val="700"/>
+              </a:spcAft>
+              <a:defRPr sz="1900" b="0">
+                <a:solidFill>
+                  <a:srgbClr val="148D91"/>
+                </a:solidFill>
+                <a:latin typeface="Noto Sans CJK SC"/>
+              </a:defRPr>
+            </a:pPr>
+            <a:r>
+              <a:t>∑ᵢ bᵢ αᵢ</a:t>
+            </a:r>
+          </a:p>
+        </p:txBody>
+      </p:sp>
+      <p:sp>
+        <p:nvSpPr>
+          <p:cNvPr id="19" name="TextBox 18"/>
+          <p:cNvSpPr txBox="1"/>
+          <p:nvPr/>
+        </p:nvSpPr>
+        <p:spPr>
+          <a:xfrm>
+            <a:off x="685800" y="3410712"/>
+            <a:ext cx="10826496" cy="256032"/>
           </a:xfrm>
           <a:prstGeom prst="rect">
             <a:avLst/>
@@ -5161,27 +4268,27 @@
               </a:spcAft>
               <a:defRPr sz="1200" b="0">
                 <a:solidFill>
-                  <a:srgbClr val="142B46"/>
+                  <a:srgbClr val="62748A"/>
                 </a:solidFill>
                 <a:latin typeface="Noto Sans CJK SC"/>
               </a:defRPr>
             </a:pPr>
             <a:r>
-              <a:t>D｜曲率分档 1 / 1.5 / 3</a:t>
-            </a:r>
-          </a:p>
-        </p:txBody>
-      </p:sp>
-      <p:sp>
-        <p:nvSpPr>
-          <p:cNvPr id="42" name="TextBox 41"/>
+              <a:t>ℓᵢ：单样本方向损失；bᵢ：原有目标距离权重；αᵢ：本次新增的转弯权重。</a:t>
+            </a:r>
+          </a:p>
+        </p:txBody>
+      </p:sp>
+      <p:sp>
+        <p:nvSpPr>
+          <p:cNvPr id="20" name="TextBox 19"/>
           <p:cNvSpPr txBox="1"/>
           <p:nvPr/>
         </p:nvSpPr>
         <p:spPr>
           <a:xfrm>
-            <a:off x="4005072" y="5303520"/>
-            <a:ext cx="1773936" cy="283464"/>
+            <a:off x="685800" y="3749039"/>
+            <a:ext cx="10826496" cy="256032"/>
           </a:xfrm>
           <a:prstGeom prst="rect">
             <a:avLst/>
@@ -5195,11 +4302,11 @@
           </a:bodyPr>
           <a:lstStyle/>
           <a:p>
-            <a:pPr algn="ctr">
+            <a:pPr>
               <a:spcAft>
                 <a:spcPts val="700"/>
               </a:spcAft>
-              <a:defRPr sz="1400" b="0">
+              <a:defRPr sz="1100" b="0">
                 <a:solidFill>
                   <a:srgbClr val="142B46"/>
                 </a:solidFill>
@@ -5207,21 +4314,147 @@
               </a:defRPr>
             </a:pPr>
             <a:r>
-              <a:t>8.07°</a:t>
-            </a:r>
-          </a:p>
-        </p:txBody>
-      </p:sp>
-      <p:sp>
-        <p:nvSpPr>
-          <p:cNvPr id="43" name="TextBox 42"/>
+              <a:t>B：转弯 α=2；C：转弯 α=3（其他样本均为 1）；D：累计转角低 / 中 / 高三档 α=1 / 1.5 / 3。</a:t>
+            </a:r>
+          </a:p>
+        </p:txBody>
+      </p:sp>
+      <p:sp>
+        <p:nvSpPr>
+          <p:cNvPr id="21" name="TextBox 20"/>
           <p:cNvSpPr txBox="1"/>
           <p:nvPr/>
         </p:nvSpPr>
         <p:spPr>
           <a:xfrm>
-            <a:off x="5870448" y="5303520"/>
-            <a:ext cx="1773936" cy="283464"/>
+            <a:off x="685800" y="4078224"/>
+            <a:ext cx="10826496" cy="228600"/>
+          </a:xfrm>
+          <a:prstGeom prst="rect">
+            <a:avLst/>
+          </a:prstGeom>
+          <a:noFill/>
+          <a:effectLst/>
+        </p:spPr>
+        <p:txBody>
+          <a:bodyPr wrap="none" lIns="0" rIns="0" tIns="0" bIns="0">
+            <a:spAutoFit/>
+          </a:bodyPr>
+          <a:lstStyle/>
+          <a:p>
+            <a:pPr>
+              <a:spcAft>
+                <a:spcPts val="700"/>
+              </a:spcAft>
+              <a:defRPr sz="1100" b="0">
+                <a:solidFill>
+                  <a:srgbClr val="62748A"/>
+                </a:solidFill>
+                <a:latin typeface="Noto Sans CJK SC"/>
+              </a:defRPr>
+            </a:pPr>
+            <a:r>
+              <a:t>ℓᵢ 的计算：预热时 1−cosθᵢ；后续为 −κᵢ cosθᵢ + log I₀(κᵢ)（θᵢ 为方向误差，κᵢ 为方向集中度）。</a:t>
+            </a:r>
+          </a:p>
+        </p:txBody>
+      </p:sp>
+      <p:sp>
+        <p:nvSpPr>
+          <p:cNvPr id="22" name="Rounded Rectangle 21"/>
+          <p:cNvSpPr/>
+          <p:nvPr/>
+        </p:nvSpPr>
+        <p:spPr>
+          <a:xfrm>
+            <a:off x="685800" y="4453128"/>
+            <a:ext cx="10826496" cy="329184"/>
+          </a:xfrm>
+          <a:prstGeom prst="roundRect">
+            <a:avLst>
+              <a:gd name="adj" fmla="val 12000"/>
+            </a:avLst>
+          </a:prstGeom>
+          <a:solidFill>
+            <a:srgbClr val="ECF1F7"/>
+          </a:solidFill>
+          <a:ln>
+            <a:noFill/>
+          </a:ln>
+          <a:effectLst/>
+        </p:spPr>
+        <p:style>
+          <a:lnRef idx="1">
+            <a:schemeClr val="accent1"/>
+          </a:lnRef>
+          <a:fillRef idx="3">
+            <a:schemeClr val="accent1"/>
+          </a:fillRef>
+          <a:effectRef idx="0">
+            <a:schemeClr val="accent1"/>
+          </a:effectRef>
+          <a:fontRef idx="minor">
+            <a:schemeClr val="lt1"/>
+          </a:fontRef>
+        </p:style>
+        <p:txBody>
+          <a:bodyPr rtlCol="0" anchor="ctr"/>
+          <a:lstStyle/>
+          <a:p>
+            <a:pPr algn="ctr"/>
+          </a:p>
+        </p:txBody>
+      </p:sp>
+      <p:sp>
+        <p:nvSpPr>
+          <p:cNvPr id="23" name="TextBox 22"/>
+          <p:cNvSpPr txBox="1"/>
+          <p:nvPr/>
+        </p:nvSpPr>
+        <p:spPr>
+          <a:xfrm>
+            <a:off x="841248" y="4526280"/>
+            <a:ext cx="2834640" cy="219456"/>
+          </a:xfrm>
+          <a:prstGeom prst="rect">
+            <a:avLst/>
+          </a:prstGeom>
+          <a:noFill/>
+          <a:effectLst/>
+        </p:spPr>
+        <p:txBody>
+          <a:bodyPr wrap="none" lIns="0" rIns="0" tIns="0" bIns="0">
+            <a:spAutoFit/>
+          </a:bodyPr>
+          <a:lstStyle/>
+          <a:p>
+            <a:pPr>
+              <a:spcAft>
+                <a:spcPts val="700"/>
+              </a:spcAft>
+              <a:defRPr sz="1100" b="1">
+                <a:solidFill>
+                  <a:srgbClr val="62748A"/>
+                </a:solidFill>
+                <a:latin typeface="Noto Sans CJK SC"/>
+              </a:defRPr>
+            </a:pPr>
+            <a:r>
+              <a:t>WP 训练方案</a:t>
+            </a:r>
+          </a:p>
+        </p:txBody>
+      </p:sp>
+      <p:sp>
+        <p:nvSpPr>
+          <p:cNvPr id="24" name="TextBox 23"/>
+          <p:cNvSpPr txBox="1"/>
+          <p:nvPr/>
+        </p:nvSpPr>
+        <p:spPr>
+          <a:xfrm>
+            <a:off x="4005072" y="4526280"/>
+            <a:ext cx="1773936" cy="219456"/>
           </a:xfrm>
           <a:prstGeom prst="rect">
             <a:avLst/>
@@ -5239,7 +4472,253 @@
               <a:spcAft>
                 <a:spcPts val="700"/>
               </a:spcAft>
-              <a:defRPr sz="1400" b="1">
+              <a:defRPr sz="1000" b="1">
+                <a:solidFill>
+                  <a:srgbClr val="62748A"/>
+                </a:solidFill>
+                <a:latin typeface="Noto Sans CJK SC"/>
+              </a:defRPr>
+            </a:pPr>
+            <a:r>
+              <a:t>全量中位误差 ↓</a:t>
+            </a:r>
+          </a:p>
+        </p:txBody>
+      </p:sp>
+      <p:sp>
+        <p:nvSpPr>
+          <p:cNvPr id="25" name="TextBox 24"/>
+          <p:cNvSpPr txBox="1"/>
+          <p:nvPr/>
+        </p:nvSpPr>
+        <p:spPr>
+          <a:xfrm>
+            <a:off x="5870448" y="4526280"/>
+            <a:ext cx="1773936" cy="219456"/>
+          </a:xfrm>
+          <a:prstGeom prst="rect">
+            <a:avLst/>
+          </a:prstGeom>
+          <a:noFill/>
+          <a:effectLst/>
+        </p:spPr>
+        <p:txBody>
+          <a:bodyPr wrap="none" lIns="0" rIns="0" tIns="0" bIns="0">
+            <a:spAutoFit/>
+          </a:bodyPr>
+          <a:lstStyle/>
+          <a:p>
+            <a:pPr algn="ctr">
+              <a:spcAft>
+                <a:spcPts val="700"/>
+              </a:spcAft>
+              <a:defRPr sz="1000" b="1">
+                <a:solidFill>
+                  <a:srgbClr val="62748A"/>
+                </a:solidFill>
+                <a:latin typeface="Noto Sans CJK SC"/>
+              </a:defRPr>
+            </a:pPr>
+            <a:r>
+              <a:t>转弯中位误差 ↓</a:t>
+            </a:r>
+          </a:p>
+        </p:txBody>
+      </p:sp>
+      <p:sp>
+        <p:nvSpPr>
+          <p:cNvPr id="26" name="TextBox 25"/>
+          <p:cNvSpPr txBox="1"/>
+          <p:nvPr/>
+        </p:nvSpPr>
+        <p:spPr>
+          <a:xfrm>
+            <a:off x="7735824" y="4526280"/>
+            <a:ext cx="1773936" cy="219456"/>
+          </a:xfrm>
+          <a:prstGeom prst="rect">
+            <a:avLst/>
+          </a:prstGeom>
+          <a:noFill/>
+          <a:effectLst/>
+        </p:spPr>
+        <p:txBody>
+          <a:bodyPr wrap="none" lIns="0" rIns="0" tIns="0" bIns="0">
+            <a:spAutoFit/>
+          </a:bodyPr>
+          <a:lstStyle/>
+          <a:p>
+            <a:pPr algn="ctr">
+              <a:spcAft>
+                <a:spcPts val="700"/>
+              </a:spcAft>
+              <a:defRPr sz="1000" b="1">
+                <a:solidFill>
+                  <a:srgbClr val="62748A"/>
+                </a:solidFill>
+                <a:latin typeface="Noto Sans CJK SC"/>
+              </a:defRPr>
+            </a:pPr>
+            <a:r>
+              <a:t>转弯 P90 ↓</a:t>
+            </a:r>
+          </a:p>
+        </p:txBody>
+      </p:sp>
+      <p:sp>
+        <p:nvSpPr>
+          <p:cNvPr id="27" name="TextBox 26"/>
+          <p:cNvSpPr txBox="1"/>
+          <p:nvPr/>
+        </p:nvSpPr>
+        <p:spPr>
+          <a:xfrm>
+            <a:off x="9601200" y="4526280"/>
+            <a:ext cx="1911095" cy="219456"/>
+          </a:xfrm>
+          <a:prstGeom prst="rect">
+            <a:avLst/>
+          </a:prstGeom>
+          <a:noFill/>
+          <a:effectLst/>
+        </p:spPr>
+        <p:txBody>
+          <a:bodyPr wrap="none" lIns="0" rIns="0" tIns="0" bIns="0">
+            <a:spAutoFit/>
+          </a:bodyPr>
+          <a:lstStyle/>
+          <a:p>
+            <a:pPr algn="ctr">
+              <a:spcAft>
+                <a:spcPts val="700"/>
+              </a:spcAft>
+              <a:defRPr sz="1000" b="1">
+                <a:solidFill>
+                  <a:srgbClr val="62748A"/>
+                </a:solidFill>
+                <a:latin typeface="Noto Sans CJK SC"/>
+              </a:defRPr>
+            </a:pPr>
+            <a:r>
+              <a:t>全量 &gt;45° 占比 ↓</a:t>
+            </a:r>
+          </a:p>
+        </p:txBody>
+      </p:sp>
+      <p:sp>
+        <p:nvSpPr>
+          <p:cNvPr id="28" name="Rounded Rectangle 27"/>
+          <p:cNvSpPr/>
+          <p:nvPr/>
+        </p:nvSpPr>
+        <p:spPr>
+          <a:xfrm>
+            <a:off x="685800" y="4882896"/>
+            <a:ext cx="10826496" cy="265176"/>
+          </a:xfrm>
+          <a:prstGeom prst="roundRect">
+            <a:avLst>
+              <a:gd name="adj" fmla="val 12000"/>
+            </a:avLst>
+          </a:prstGeom>
+          <a:solidFill>
+            <a:srgbClr val="E8F4F2"/>
+          </a:solidFill>
+          <a:ln>
+            <a:noFill/>
+          </a:ln>
+          <a:effectLst/>
+        </p:spPr>
+        <p:style>
+          <a:lnRef idx="1">
+            <a:schemeClr val="accent1"/>
+          </a:lnRef>
+          <a:fillRef idx="3">
+            <a:schemeClr val="accent1"/>
+          </a:fillRef>
+          <a:effectRef idx="0">
+            <a:schemeClr val="accent1"/>
+          </a:effectRef>
+          <a:fontRef idx="minor">
+            <a:schemeClr val="lt1"/>
+          </a:fontRef>
+        </p:style>
+        <p:txBody>
+          <a:bodyPr rtlCol="0" anchor="ctr"/>
+          <a:lstStyle/>
+          <a:p>
+            <a:pPr algn="ctr"/>
+          </a:p>
+        </p:txBody>
+      </p:sp>
+      <p:sp>
+        <p:nvSpPr>
+          <p:cNvPr id="29" name="TextBox 28"/>
+          <p:cNvSpPr txBox="1"/>
+          <p:nvPr/>
+        </p:nvSpPr>
+        <p:spPr>
+          <a:xfrm>
+            <a:off x="841248" y="4901184"/>
+            <a:ext cx="3108960" cy="237744"/>
+          </a:xfrm>
+          <a:prstGeom prst="rect">
+            <a:avLst/>
+          </a:prstGeom>
+          <a:noFill/>
+          <a:effectLst/>
+        </p:spPr>
+        <p:txBody>
+          <a:bodyPr wrap="none" lIns="0" rIns="0" tIns="0" bIns="0">
+            <a:spAutoFit/>
+          </a:bodyPr>
+          <a:lstStyle/>
+          <a:p>
+            <a:pPr>
+              <a:spcAft>
+                <a:spcPts val="700"/>
+              </a:spcAft>
+              <a:defRPr sz="1100" b="1">
+                <a:solidFill>
+                  <a:srgbClr val="142B46"/>
+                </a:solidFill>
+                <a:latin typeface="Noto Sans CJK SC"/>
+              </a:defRPr>
+            </a:pPr>
+            <a:r>
+              <a:t>ctx2｜仅原有距离权重</a:t>
+            </a:r>
+          </a:p>
+        </p:txBody>
+      </p:sp>
+      <p:sp>
+        <p:nvSpPr>
+          <p:cNvPr id="30" name="TextBox 29"/>
+          <p:cNvSpPr txBox="1"/>
+          <p:nvPr/>
+        </p:nvSpPr>
+        <p:spPr>
+          <a:xfrm>
+            <a:off x="4005072" y="4901184"/>
+            <a:ext cx="1773936" cy="246888"/>
+          </a:xfrm>
+          <a:prstGeom prst="rect">
+            <a:avLst/>
+          </a:prstGeom>
+          <a:noFill/>
+          <a:effectLst/>
+        </p:spPr>
+        <p:txBody>
+          <a:bodyPr wrap="none" lIns="0" rIns="0" tIns="0" bIns="0">
+            <a:spAutoFit/>
+          </a:bodyPr>
+          <a:lstStyle/>
+          <a:p>
+            <a:pPr algn="ctr">
+              <a:spcAft>
+                <a:spcPts val="700"/>
+              </a:spcAft>
+              <a:defRPr sz="1300" b="1">
                 <a:solidFill>
                   <a:srgbClr val="148D91"/>
                 </a:solidFill>
@@ -5247,21 +4726,21 @@
               </a:defRPr>
             </a:pPr>
             <a:r>
-              <a:t>11.98°</a:t>
-            </a:r>
-          </a:p>
-        </p:txBody>
-      </p:sp>
-      <p:sp>
-        <p:nvSpPr>
-          <p:cNvPr id="44" name="TextBox 43"/>
+              <a:t>7.97°</a:t>
+            </a:r>
+          </a:p>
+        </p:txBody>
+      </p:sp>
+      <p:sp>
+        <p:nvSpPr>
+          <p:cNvPr id="31" name="TextBox 30"/>
           <p:cNvSpPr txBox="1"/>
           <p:nvPr/>
         </p:nvSpPr>
         <p:spPr>
           <a:xfrm>
-            <a:off x="7735824" y="5303520"/>
-            <a:ext cx="1773936" cy="283464"/>
+            <a:off x="5870448" y="4901184"/>
+            <a:ext cx="1773936" cy="246888"/>
           </a:xfrm>
           <a:prstGeom prst="rect">
             <a:avLst/>
@@ -5279,7 +4758,7 @@
               <a:spcAft>
                 <a:spcPts val="700"/>
               </a:spcAft>
-              <a:defRPr sz="1400" b="0">
+              <a:defRPr sz="1300" b="1">
                 <a:solidFill>
                   <a:srgbClr val="142B46"/>
                 </a:solidFill>
@@ -5287,21 +4766,21 @@
               </a:defRPr>
             </a:pPr>
             <a:r>
-              <a:t>53.95°</a:t>
-            </a:r>
-          </a:p>
-        </p:txBody>
-      </p:sp>
-      <p:sp>
-        <p:nvSpPr>
-          <p:cNvPr id="45" name="TextBox 44"/>
+              <a:t>13.02°</a:t>
+            </a:r>
+          </a:p>
+        </p:txBody>
+      </p:sp>
+      <p:sp>
+        <p:nvSpPr>
+          <p:cNvPr id="32" name="TextBox 31"/>
           <p:cNvSpPr txBox="1"/>
           <p:nvPr/>
         </p:nvSpPr>
         <p:spPr>
           <a:xfrm>
-            <a:off x="9601200" y="5303520"/>
-            <a:ext cx="1911095" cy="283464"/>
+            <a:off x="7735824" y="4901184"/>
+            <a:ext cx="1773936" cy="246888"/>
           </a:xfrm>
           <a:prstGeom prst="rect">
             <a:avLst/>
@@ -5319,7 +4798,87 @@
               <a:spcAft>
                 <a:spcPts val="700"/>
               </a:spcAft>
-              <a:defRPr sz="1400" b="0">
+              <a:defRPr sz="1300" b="1">
+                <a:solidFill>
+                  <a:srgbClr val="148D91"/>
+                </a:solidFill>
+                <a:latin typeface="Noto Sans CJK SC"/>
+              </a:defRPr>
+            </a:pPr>
+            <a:r>
+              <a:t>53.12°</a:t>
+            </a:r>
+          </a:p>
+        </p:txBody>
+      </p:sp>
+      <p:sp>
+        <p:nvSpPr>
+          <p:cNvPr id="33" name="TextBox 32"/>
+          <p:cNvSpPr txBox="1"/>
+          <p:nvPr/>
+        </p:nvSpPr>
+        <p:spPr>
+          <a:xfrm>
+            <a:off x="9601200" y="4901184"/>
+            <a:ext cx="1911095" cy="246888"/>
+          </a:xfrm>
+          <a:prstGeom prst="rect">
+            <a:avLst/>
+          </a:prstGeom>
+          <a:noFill/>
+          <a:effectLst/>
+        </p:spPr>
+        <p:txBody>
+          <a:bodyPr wrap="none" lIns="0" rIns="0" tIns="0" bIns="0">
+            <a:spAutoFit/>
+          </a:bodyPr>
+          <a:lstStyle/>
+          <a:p>
+            <a:pPr algn="ctr">
+              <a:spcAft>
+                <a:spcPts val="700"/>
+              </a:spcAft>
+              <a:defRPr sz="1300" b="1">
+                <a:solidFill>
+                  <a:srgbClr val="148D91"/>
+                </a:solidFill>
+                <a:latin typeface="Noto Sans CJK SC"/>
+              </a:defRPr>
+            </a:pPr>
+            <a:r>
+              <a:t>7.08%</a:t>
+            </a:r>
+          </a:p>
+        </p:txBody>
+      </p:sp>
+      <p:sp>
+        <p:nvSpPr>
+          <p:cNvPr id="34" name="TextBox 33"/>
+          <p:cNvSpPr txBox="1"/>
+          <p:nvPr/>
+        </p:nvSpPr>
+        <p:spPr>
+          <a:xfrm>
+            <a:off x="841248" y="5175504"/>
+            <a:ext cx="3108960" cy="237744"/>
+          </a:xfrm>
+          <a:prstGeom prst="rect">
+            <a:avLst/>
+          </a:prstGeom>
+          <a:noFill/>
+          <a:effectLst/>
+        </p:spPr>
+        <p:txBody>
+          <a:bodyPr wrap="none" lIns="0" rIns="0" tIns="0" bIns="0">
+            <a:spAutoFit/>
+          </a:bodyPr>
+          <a:lstStyle/>
+          <a:p>
+            <a:pPr>
+              <a:spcAft>
+                <a:spcPts val="700"/>
+              </a:spcAft>
+              <a:defRPr sz="1100" b="0">
                 <a:solidFill>
                   <a:srgbClr val="142B46"/>
                 </a:solidFill>
@@ -5327,26 +4886,186 @@
               </a:defRPr>
             </a:pPr>
             <a:r>
-              <a:t>7.75%</a:t>
+              <a:t>B｜严格转弯 ×2</a:t>
+            </a:r>
+          </a:p>
+        </p:txBody>
+      </p:sp>
+      <p:sp>
+        <p:nvSpPr>
+          <p:cNvPr id="35" name="TextBox 34"/>
+          <p:cNvSpPr txBox="1"/>
+          <p:nvPr/>
+        </p:nvSpPr>
+        <p:spPr>
+          <a:xfrm>
+            <a:off x="4005072" y="5175504"/>
+            <a:ext cx="1773936" cy="246888"/>
+          </a:xfrm>
+          <a:prstGeom prst="rect">
+            <a:avLst/>
+          </a:prstGeom>
+          <a:noFill/>
+          <a:effectLst/>
+        </p:spPr>
+        <p:txBody>
+          <a:bodyPr wrap="none" lIns="0" rIns="0" tIns="0" bIns="0">
+            <a:spAutoFit/>
+          </a:bodyPr>
+          <a:lstStyle/>
+          <a:p>
+            <a:pPr algn="ctr">
+              <a:spcAft>
+                <a:spcPts val="700"/>
+              </a:spcAft>
+              <a:defRPr sz="1300" b="0">
+                <a:solidFill>
+                  <a:srgbClr val="142B46"/>
+                </a:solidFill>
+                <a:latin typeface="Noto Sans CJK SC"/>
+              </a:defRPr>
+            </a:pPr>
+            <a:r>
+              <a:t>8.04°</a:t>
+            </a:r>
+          </a:p>
+        </p:txBody>
+      </p:sp>
+      <p:sp>
+        <p:nvSpPr>
+          <p:cNvPr id="36" name="TextBox 35"/>
+          <p:cNvSpPr txBox="1"/>
+          <p:nvPr/>
+        </p:nvSpPr>
+        <p:spPr>
+          <a:xfrm>
+            <a:off x="5870448" y="5175504"/>
+            <a:ext cx="1773936" cy="246888"/>
+          </a:xfrm>
+          <a:prstGeom prst="rect">
+            <a:avLst/>
+          </a:prstGeom>
+          <a:noFill/>
+          <a:effectLst/>
+        </p:spPr>
+        <p:txBody>
+          <a:bodyPr wrap="none" lIns="0" rIns="0" tIns="0" bIns="0">
+            <a:spAutoFit/>
+          </a:bodyPr>
+          <a:lstStyle/>
+          <a:p>
+            <a:pPr algn="ctr">
+              <a:spcAft>
+                <a:spcPts val="700"/>
+              </a:spcAft>
+              <a:defRPr sz="1300" b="1">
+                <a:solidFill>
+                  <a:srgbClr val="148D91"/>
+                </a:solidFill>
+                <a:latin typeface="Noto Sans CJK SC"/>
+              </a:defRPr>
+            </a:pPr>
+            <a:r>
+              <a:t>12.11°</a:t>
+            </a:r>
+          </a:p>
+        </p:txBody>
+      </p:sp>
+      <p:sp>
+        <p:nvSpPr>
+          <p:cNvPr id="37" name="TextBox 36"/>
+          <p:cNvSpPr txBox="1"/>
+          <p:nvPr/>
+        </p:nvSpPr>
+        <p:spPr>
+          <a:xfrm>
+            <a:off x="7735824" y="5175504"/>
+            <a:ext cx="1773936" cy="246888"/>
+          </a:xfrm>
+          <a:prstGeom prst="rect">
+            <a:avLst/>
+          </a:prstGeom>
+          <a:noFill/>
+          <a:effectLst/>
+        </p:spPr>
+        <p:txBody>
+          <a:bodyPr wrap="none" lIns="0" rIns="0" tIns="0" bIns="0">
+            <a:spAutoFit/>
+          </a:bodyPr>
+          <a:lstStyle/>
+          <a:p>
+            <a:pPr algn="ctr">
+              <a:spcAft>
+                <a:spcPts val="700"/>
+              </a:spcAft>
+              <a:defRPr sz="1300" b="0">
+                <a:solidFill>
+                  <a:srgbClr val="142B46"/>
+                </a:solidFill>
+                <a:latin typeface="Noto Sans CJK SC"/>
+              </a:defRPr>
+            </a:pPr>
+            <a:r>
+              <a:t>55.77°</a:t>
+            </a:r>
+          </a:p>
+        </p:txBody>
+      </p:sp>
+      <p:sp>
+        <p:nvSpPr>
+          <p:cNvPr id="38" name="TextBox 37"/>
+          <p:cNvSpPr txBox="1"/>
+          <p:nvPr/>
+        </p:nvSpPr>
+        <p:spPr>
+          <a:xfrm>
+            <a:off x="9601200" y="5175504"/>
+            <a:ext cx="1911095" cy="246888"/>
+          </a:xfrm>
+          <a:prstGeom prst="rect">
+            <a:avLst/>
+          </a:prstGeom>
+          <a:noFill/>
+          <a:effectLst/>
+        </p:spPr>
+        <p:txBody>
+          <a:bodyPr wrap="none" lIns="0" rIns="0" tIns="0" bIns="0">
+            <a:spAutoFit/>
+          </a:bodyPr>
+          <a:lstStyle/>
+          <a:p>
+            <a:pPr algn="ctr">
+              <a:spcAft>
+                <a:spcPts val="700"/>
+              </a:spcAft>
+              <a:defRPr sz="1300" b="0">
+                <a:solidFill>
+                  <a:srgbClr val="142B46"/>
+                </a:solidFill>
+                <a:latin typeface="Noto Sans CJK SC"/>
+              </a:defRPr>
+            </a:pPr>
+            <a:r>
+              <a:t>8.04%</a:t>
             </a:r>
           </a:p>
         </p:txBody>
       </p:sp>
       <p:cxnSp>
         <p:nvCxnSpPr>
-          <p:cNvPr id="46" name="Connector 45"/>
+          <p:cNvPr id="39" name="Connector 38"/>
           <p:cNvCxnSpPr/>
           <p:nvPr/>
         </p:nvCxnSpPr>
         <p:spPr>
           <a:xfrm>
-            <a:off x="685800" y="5614416"/>
+            <a:off x="685800" y="5422392"/>
             <a:ext cx="10826496" cy="0"/>
           </a:xfrm>
           <a:prstGeom prst="line">
             <a:avLst/>
           </a:prstGeom>
-          <a:ln w="8255">
+          <a:ln w="6985">
             <a:solidFill>
               <a:srgbClr val="DCE5EF"/>
             </a:solidFill>
@@ -5370,14 +5089,14 @@
       </p:cxnSp>
       <p:sp>
         <p:nvSpPr>
-          <p:cNvPr id="47" name="TextBox 46"/>
+          <p:cNvPr id="40" name="TextBox 39"/>
           <p:cNvSpPr txBox="1"/>
           <p:nvPr/>
         </p:nvSpPr>
         <p:spPr>
           <a:xfrm>
-            <a:off x="685800" y="5769864"/>
-            <a:ext cx="10789920" cy="228600"/>
+            <a:off x="841248" y="5449824"/>
+            <a:ext cx="3108960" cy="237744"/>
           </a:xfrm>
           <a:prstGeom prst="rect">
             <a:avLst/>
@@ -5395,7 +5114,479 @@
               <a:spcAft>
                 <a:spcPts val="700"/>
               </a:spcAft>
-              <a:defRPr sz="1000" b="0">
+              <a:defRPr sz="1100" b="0">
+                <a:solidFill>
+                  <a:srgbClr val="142B46"/>
+                </a:solidFill>
+                <a:latin typeface="Noto Sans CJK SC"/>
+              </a:defRPr>
+            </a:pPr>
+            <a:r>
+              <a:t>C｜严格转弯 ×3</a:t>
+            </a:r>
+          </a:p>
+        </p:txBody>
+      </p:sp>
+      <p:sp>
+        <p:nvSpPr>
+          <p:cNvPr id="41" name="TextBox 40"/>
+          <p:cNvSpPr txBox="1"/>
+          <p:nvPr/>
+        </p:nvSpPr>
+        <p:spPr>
+          <a:xfrm>
+            <a:off x="4005072" y="5449824"/>
+            <a:ext cx="1773936" cy="246888"/>
+          </a:xfrm>
+          <a:prstGeom prst="rect">
+            <a:avLst/>
+          </a:prstGeom>
+          <a:noFill/>
+          <a:effectLst/>
+        </p:spPr>
+        <p:txBody>
+          <a:bodyPr wrap="none" lIns="0" rIns="0" tIns="0" bIns="0">
+            <a:spAutoFit/>
+          </a:bodyPr>
+          <a:lstStyle/>
+          <a:p>
+            <a:pPr algn="ctr">
+              <a:spcAft>
+                <a:spcPts val="700"/>
+              </a:spcAft>
+              <a:defRPr sz="1300" b="0">
+                <a:solidFill>
+                  <a:srgbClr val="142B46"/>
+                </a:solidFill>
+                <a:latin typeface="Noto Sans CJK SC"/>
+              </a:defRPr>
+            </a:pPr>
+            <a:r>
+              <a:t>8.11°</a:t>
+            </a:r>
+          </a:p>
+        </p:txBody>
+      </p:sp>
+      <p:sp>
+        <p:nvSpPr>
+          <p:cNvPr id="42" name="TextBox 41"/>
+          <p:cNvSpPr txBox="1"/>
+          <p:nvPr/>
+        </p:nvSpPr>
+        <p:spPr>
+          <a:xfrm>
+            <a:off x="5870448" y="5449824"/>
+            <a:ext cx="1773936" cy="246888"/>
+          </a:xfrm>
+          <a:prstGeom prst="rect">
+            <a:avLst/>
+          </a:prstGeom>
+          <a:noFill/>
+          <a:effectLst/>
+        </p:spPr>
+        <p:txBody>
+          <a:bodyPr wrap="none" lIns="0" rIns="0" tIns="0" bIns="0">
+            <a:spAutoFit/>
+          </a:bodyPr>
+          <a:lstStyle/>
+          <a:p>
+            <a:pPr algn="ctr">
+              <a:spcAft>
+                <a:spcPts val="700"/>
+              </a:spcAft>
+              <a:defRPr sz="1300" b="1">
+                <a:solidFill>
+                  <a:srgbClr val="148D91"/>
+                </a:solidFill>
+                <a:latin typeface="Noto Sans CJK SC"/>
+              </a:defRPr>
+            </a:pPr>
+            <a:r>
+              <a:t>12.55°</a:t>
+            </a:r>
+          </a:p>
+        </p:txBody>
+      </p:sp>
+      <p:sp>
+        <p:nvSpPr>
+          <p:cNvPr id="43" name="TextBox 42"/>
+          <p:cNvSpPr txBox="1"/>
+          <p:nvPr/>
+        </p:nvSpPr>
+        <p:spPr>
+          <a:xfrm>
+            <a:off x="7735824" y="5449824"/>
+            <a:ext cx="1773936" cy="246888"/>
+          </a:xfrm>
+          <a:prstGeom prst="rect">
+            <a:avLst/>
+          </a:prstGeom>
+          <a:noFill/>
+          <a:effectLst/>
+        </p:spPr>
+        <p:txBody>
+          <a:bodyPr wrap="none" lIns="0" rIns="0" tIns="0" bIns="0">
+            <a:spAutoFit/>
+          </a:bodyPr>
+          <a:lstStyle/>
+          <a:p>
+            <a:pPr algn="ctr">
+              <a:spcAft>
+                <a:spcPts val="700"/>
+              </a:spcAft>
+              <a:defRPr sz="1300" b="0">
+                <a:solidFill>
+                  <a:srgbClr val="142B46"/>
+                </a:solidFill>
+                <a:latin typeface="Noto Sans CJK SC"/>
+              </a:defRPr>
+            </a:pPr>
+            <a:r>
+              <a:t>54.01°</a:t>
+            </a:r>
+          </a:p>
+        </p:txBody>
+      </p:sp>
+      <p:sp>
+        <p:nvSpPr>
+          <p:cNvPr id="44" name="TextBox 43"/>
+          <p:cNvSpPr txBox="1"/>
+          <p:nvPr/>
+        </p:nvSpPr>
+        <p:spPr>
+          <a:xfrm>
+            <a:off x="9601200" y="5449824"/>
+            <a:ext cx="1911095" cy="246888"/>
+          </a:xfrm>
+          <a:prstGeom prst="rect">
+            <a:avLst/>
+          </a:prstGeom>
+          <a:noFill/>
+          <a:effectLst/>
+        </p:spPr>
+        <p:txBody>
+          <a:bodyPr wrap="none" lIns="0" rIns="0" tIns="0" bIns="0">
+            <a:spAutoFit/>
+          </a:bodyPr>
+          <a:lstStyle/>
+          <a:p>
+            <a:pPr algn="ctr">
+              <a:spcAft>
+                <a:spcPts val="700"/>
+              </a:spcAft>
+              <a:defRPr sz="1300" b="0">
+                <a:solidFill>
+                  <a:srgbClr val="142B46"/>
+                </a:solidFill>
+                <a:latin typeface="Noto Sans CJK SC"/>
+              </a:defRPr>
+            </a:pPr>
+            <a:r>
+              <a:t>7.44%</a:t>
+            </a:r>
+          </a:p>
+        </p:txBody>
+      </p:sp>
+      <p:cxnSp>
+        <p:nvCxnSpPr>
+          <p:cNvPr id="45" name="Connector 44"/>
+          <p:cNvCxnSpPr/>
+          <p:nvPr/>
+        </p:nvCxnSpPr>
+        <p:spPr>
+          <a:xfrm>
+            <a:off x="685800" y="5696712"/>
+            <a:ext cx="10826496" cy="0"/>
+          </a:xfrm>
+          <a:prstGeom prst="line">
+            <a:avLst/>
+          </a:prstGeom>
+          <a:ln w="6985">
+            <a:solidFill>
+              <a:srgbClr val="DCE5EF"/>
+            </a:solidFill>
+          </a:ln>
+          <a:effectLst/>
+        </p:spPr>
+        <p:style>
+          <a:lnRef idx="2">
+            <a:schemeClr val="accent1"/>
+          </a:lnRef>
+          <a:fillRef idx="0">
+            <a:schemeClr val="accent1"/>
+          </a:fillRef>
+          <a:effectRef idx="0">
+            <a:schemeClr val="accent1"/>
+          </a:effectRef>
+          <a:fontRef idx="minor">
+            <a:schemeClr val="tx1"/>
+          </a:fontRef>
+        </p:style>
+      </p:cxnSp>
+      <p:sp>
+        <p:nvSpPr>
+          <p:cNvPr id="46" name="TextBox 45"/>
+          <p:cNvSpPr txBox="1"/>
+          <p:nvPr/>
+        </p:nvSpPr>
+        <p:spPr>
+          <a:xfrm>
+            <a:off x="841248" y="5724144"/>
+            <a:ext cx="3108960" cy="237744"/>
+          </a:xfrm>
+          <a:prstGeom prst="rect">
+            <a:avLst/>
+          </a:prstGeom>
+          <a:noFill/>
+          <a:effectLst/>
+        </p:spPr>
+        <p:txBody>
+          <a:bodyPr wrap="none" lIns="0" rIns="0" tIns="0" bIns="0">
+            <a:spAutoFit/>
+          </a:bodyPr>
+          <a:lstStyle/>
+          <a:p>
+            <a:pPr>
+              <a:spcAft>
+                <a:spcPts val="700"/>
+              </a:spcAft>
+              <a:defRPr sz="1100" b="0">
+                <a:solidFill>
+                  <a:srgbClr val="142B46"/>
+                </a:solidFill>
+                <a:latin typeface="Noto Sans CJK SC"/>
+              </a:defRPr>
+            </a:pPr>
+            <a:r>
+              <a:t>D｜累计转角分档 1 / 1.5 / 3</a:t>
+            </a:r>
+          </a:p>
+        </p:txBody>
+      </p:sp>
+      <p:sp>
+        <p:nvSpPr>
+          <p:cNvPr id="47" name="TextBox 46"/>
+          <p:cNvSpPr txBox="1"/>
+          <p:nvPr/>
+        </p:nvSpPr>
+        <p:spPr>
+          <a:xfrm>
+            <a:off x="4005072" y="5724144"/>
+            <a:ext cx="1773936" cy="246888"/>
+          </a:xfrm>
+          <a:prstGeom prst="rect">
+            <a:avLst/>
+          </a:prstGeom>
+          <a:noFill/>
+          <a:effectLst/>
+        </p:spPr>
+        <p:txBody>
+          <a:bodyPr wrap="none" lIns="0" rIns="0" tIns="0" bIns="0">
+            <a:spAutoFit/>
+          </a:bodyPr>
+          <a:lstStyle/>
+          <a:p>
+            <a:pPr algn="ctr">
+              <a:spcAft>
+                <a:spcPts val="700"/>
+              </a:spcAft>
+              <a:defRPr sz="1300" b="0">
+                <a:solidFill>
+                  <a:srgbClr val="142B46"/>
+                </a:solidFill>
+                <a:latin typeface="Noto Sans CJK SC"/>
+              </a:defRPr>
+            </a:pPr>
+            <a:r>
+              <a:t>8.07°</a:t>
+            </a:r>
+          </a:p>
+        </p:txBody>
+      </p:sp>
+      <p:sp>
+        <p:nvSpPr>
+          <p:cNvPr id="48" name="TextBox 47"/>
+          <p:cNvSpPr txBox="1"/>
+          <p:nvPr/>
+        </p:nvSpPr>
+        <p:spPr>
+          <a:xfrm>
+            <a:off x="5870448" y="5724144"/>
+            <a:ext cx="1773936" cy="246888"/>
+          </a:xfrm>
+          <a:prstGeom prst="rect">
+            <a:avLst/>
+          </a:prstGeom>
+          <a:noFill/>
+          <a:effectLst/>
+        </p:spPr>
+        <p:txBody>
+          <a:bodyPr wrap="none" lIns="0" rIns="0" tIns="0" bIns="0">
+            <a:spAutoFit/>
+          </a:bodyPr>
+          <a:lstStyle/>
+          <a:p>
+            <a:pPr algn="ctr">
+              <a:spcAft>
+                <a:spcPts val="700"/>
+              </a:spcAft>
+              <a:defRPr sz="1300" b="1">
+                <a:solidFill>
+                  <a:srgbClr val="148D91"/>
+                </a:solidFill>
+                <a:latin typeface="Noto Sans CJK SC"/>
+              </a:defRPr>
+            </a:pPr>
+            <a:r>
+              <a:t>11.98°</a:t>
+            </a:r>
+          </a:p>
+        </p:txBody>
+      </p:sp>
+      <p:sp>
+        <p:nvSpPr>
+          <p:cNvPr id="49" name="TextBox 48"/>
+          <p:cNvSpPr txBox="1"/>
+          <p:nvPr/>
+        </p:nvSpPr>
+        <p:spPr>
+          <a:xfrm>
+            <a:off x="7735824" y="5724144"/>
+            <a:ext cx="1773936" cy="246888"/>
+          </a:xfrm>
+          <a:prstGeom prst="rect">
+            <a:avLst/>
+          </a:prstGeom>
+          <a:noFill/>
+          <a:effectLst/>
+        </p:spPr>
+        <p:txBody>
+          <a:bodyPr wrap="none" lIns="0" rIns="0" tIns="0" bIns="0">
+            <a:spAutoFit/>
+          </a:bodyPr>
+          <a:lstStyle/>
+          <a:p>
+            <a:pPr algn="ctr">
+              <a:spcAft>
+                <a:spcPts val="700"/>
+              </a:spcAft>
+              <a:defRPr sz="1300" b="0">
+                <a:solidFill>
+                  <a:srgbClr val="142B46"/>
+                </a:solidFill>
+                <a:latin typeface="Noto Sans CJK SC"/>
+              </a:defRPr>
+            </a:pPr>
+            <a:r>
+              <a:t>53.95°</a:t>
+            </a:r>
+          </a:p>
+        </p:txBody>
+      </p:sp>
+      <p:sp>
+        <p:nvSpPr>
+          <p:cNvPr id="50" name="TextBox 49"/>
+          <p:cNvSpPr txBox="1"/>
+          <p:nvPr/>
+        </p:nvSpPr>
+        <p:spPr>
+          <a:xfrm>
+            <a:off x="9601200" y="5724144"/>
+            <a:ext cx="1911095" cy="246888"/>
+          </a:xfrm>
+          <a:prstGeom prst="rect">
+            <a:avLst/>
+          </a:prstGeom>
+          <a:noFill/>
+          <a:effectLst/>
+        </p:spPr>
+        <p:txBody>
+          <a:bodyPr wrap="none" lIns="0" rIns="0" tIns="0" bIns="0">
+            <a:spAutoFit/>
+          </a:bodyPr>
+          <a:lstStyle/>
+          <a:p>
+            <a:pPr algn="ctr">
+              <a:spcAft>
+                <a:spcPts val="700"/>
+              </a:spcAft>
+              <a:defRPr sz="1300" b="0">
+                <a:solidFill>
+                  <a:srgbClr val="142B46"/>
+                </a:solidFill>
+                <a:latin typeface="Noto Sans CJK SC"/>
+              </a:defRPr>
+            </a:pPr>
+            <a:r>
+              <a:t>7.75%</a:t>
+            </a:r>
+          </a:p>
+        </p:txBody>
+      </p:sp>
+      <p:cxnSp>
+        <p:nvCxnSpPr>
+          <p:cNvPr id="51" name="Connector 50"/>
+          <p:cNvCxnSpPr/>
+          <p:nvPr/>
+        </p:nvCxnSpPr>
+        <p:spPr>
+          <a:xfrm>
+            <a:off x="685800" y="5971031"/>
+            <a:ext cx="10826496" cy="0"/>
+          </a:xfrm>
+          <a:prstGeom prst="line">
+            <a:avLst/>
+          </a:prstGeom>
+          <a:ln w="6985">
+            <a:solidFill>
+              <a:srgbClr val="DCE5EF"/>
+            </a:solidFill>
+          </a:ln>
+          <a:effectLst/>
+        </p:spPr>
+        <p:style>
+          <a:lnRef idx="2">
+            <a:schemeClr val="accent1"/>
+          </a:lnRef>
+          <a:fillRef idx="0">
+            <a:schemeClr val="accent1"/>
+          </a:fillRef>
+          <a:effectRef idx="0">
+            <a:schemeClr val="accent1"/>
+          </a:effectRef>
+          <a:fontRef idx="minor">
+            <a:schemeClr val="tx1"/>
+          </a:fontRef>
+        </p:style>
+      </p:cxnSp>
+      <p:sp>
+        <p:nvSpPr>
+          <p:cNvPr id="52" name="TextBox 51"/>
+          <p:cNvSpPr txBox="1"/>
+          <p:nvPr/>
+        </p:nvSpPr>
+        <p:spPr>
+          <a:xfrm>
+            <a:off x="685800" y="6035040"/>
+            <a:ext cx="10826496" cy="201168"/>
+          </a:xfrm>
+          <a:prstGeom prst="rect">
+            <a:avLst/>
+          </a:prstGeom>
+          <a:noFill/>
+          <a:effectLst/>
+        </p:spPr>
+        <p:txBody>
+          <a:bodyPr wrap="none" lIns="0" rIns="0" tIns="0" bIns="0">
+            <a:spAutoFit/>
+          </a:bodyPr>
+          <a:lstStyle/>
+          <a:p>
+            <a:pPr>
+              <a:spcAft>
+                <a:spcPts val="700"/>
+              </a:spcAft>
+              <a:defRPr sz="900" b="0">
                 <a:solidFill>
                   <a:srgbClr val="62748A"/>
                 </a:solidFill>
@@ -5403,21 +5594,21 @@
               </a:defRPr>
             </a:pPr>
             <a:r>
-              <a:t>P90 反映尾部误差；本页 &gt;45° 比例的分母为全量 Val 远目标帧，与上一页转弯子集比例不同。</a:t>
-            </a:r>
-          </a:p>
-        </p:txBody>
-      </p:sp>
-      <p:sp>
-        <p:nvSpPr>
-          <p:cNvPr id="48" name="Rounded Rectangle 47"/>
+              <a:t>仅训练时增加 α；验证时取消额外转弯加权。表中 &gt;45° 比例的分母是全部 Val 远目标帧。</a:t>
+            </a:r>
+          </a:p>
+        </p:txBody>
+      </p:sp>
+      <p:sp>
+        <p:nvSpPr>
+          <p:cNvPr id="53" name="Rounded Rectangle 52"/>
           <p:cNvSpPr/>
           <p:nvPr/>
         </p:nvSpPr>
         <p:spPr>
           <a:xfrm>
-            <a:off x="685800" y="6144768"/>
-            <a:ext cx="10826496" cy="393192"/>
+            <a:off x="685800" y="6327648"/>
+            <a:ext cx="10826496" cy="320040"/>
           </a:xfrm>
           <a:prstGeom prst="roundRect">
             <a:avLst>
@@ -5456,14 +5647,14 @@
       </p:sp>
       <p:sp>
         <p:nvSpPr>
-          <p:cNvPr id="49" name="TextBox 48"/>
+          <p:cNvPr id="54" name="TextBox 53"/>
           <p:cNvSpPr txBox="1"/>
           <p:nvPr/>
         </p:nvSpPr>
         <p:spPr>
           <a:xfrm>
-            <a:off x="859536" y="6217920"/>
-            <a:ext cx="10424160" cy="265176"/>
+            <a:off x="859536" y="6373368"/>
+            <a:ext cx="10424160" cy="237744"/>
           </a:xfrm>
           <a:prstGeom prst="rect">
             <a:avLst/>
@@ -5481,7 +5672,7 @@
               <a:spcAft>
                 <a:spcPts val="700"/>
               </a:spcAft>
-              <a:defRPr sz="1400" b="1">
+              <a:defRPr sz="1300" b="1">
                 <a:solidFill>
                   <a:srgbClr val="148D91"/>
                 </a:solidFill>
@@ -5489,21 +5680,21 @@
               </a:defRPr>
             </a:pPr>
             <a:r>
-              <a:t>结论：转弯中位误差有所下降，但 P90 和全量大误差比例均未优于 ctx2。</a:t>
-            </a:r>
-          </a:p>
-        </p:txBody>
-      </p:sp>
-      <p:sp>
-        <p:nvSpPr>
-          <p:cNvPr id="50" name="TextBox 49"/>
+              <a:t>结论：转弯中位误差下降，但 P90 和全量大误差比例仍未优于 ctx2。</a:t>
+            </a:r>
+          </a:p>
+        </p:txBody>
+      </p:sp>
+      <p:sp>
+        <p:nvSpPr>
+          <p:cNvPr id="55" name="TextBox 54"/>
           <p:cNvSpPr txBox="1"/>
           <p:nvPr/>
         </p:nvSpPr>
         <p:spPr>
           <a:xfrm>
-            <a:off x="685800" y="6629400"/>
-            <a:ext cx="10058400" cy="164592"/>
+            <a:off x="685800" y="6711696"/>
+            <a:ext cx="10058400" cy="137160"/>
           </a:xfrm>
           <a:prstGeom prst="rect">
             <a:avLst/>
@@ -5521,7 +5712,7 @@
               <a:spcAft>
                 <a:spcPts val="700"/>
               </a:spcAft>
-              <a:defRPr sz="800" b="0">
+              <a:defRPr sz="700" b="0">
                 <a:solidFill>
                   <a:srgbClr val="62748A"/>
                 </a:solidFill>
@@ -5529,21 +5720,21 @@
               </a:defRPr>
             </a:pPr>
             <a:r>
-              <a:t>来源：P3_training_batch.md、p3_morning_metrics.csv；单次运行，尚需多种子验证。</a:t>
-            </a:r>
-          </a:p>
-        </p:txBody>
-      </p:sp>
-      <p:sp>
-        <p:nvSpPr>
-          <p:cNvPr id="51" name="TextBox 50"/>
+              <a:t>来源：train_goal_dino.py、train_goal_dir.py、P3_training_batch.md、p3_morning_metrics.csv；单次运行，尚需多种子验证。</a:t>
+            </a:r>
+          </a:p>
+        </p:txBody>
+      </p:sp>
+      <p:sp>
+        <p:nvSpPr>
+          <p:cNvPr id="56" name="TextBox 55"/>
           <p:cNvSpPr txBox="1"/>
           <p:nvPr/>
         </p:nvSpPr>
         <p:spPr>
           <a:xfrm>
-            <a:off x="10506456" y="6629400"/>
-            <a:ext cx="960120" cy="164592"/>
+            <a:off x="10506456" y="6711696"/>
+            <a:ext cx="960120" cy="137160"/>
           </a:xfrm>
           <a:prstGeom prst="rect">
             <a:avLst/>
@@ -5561,7 +5752,7 @@
               <a:spcAft>
                 <a:spcPts val="700"/>
               </a:spcAft>
-              <a:defRPr sz="800" b="0">
+              <a:defRPr sz="700" b="0">
                 <a:solidFill>
                   <a:srgbClr val="62748A"/>
                 </a:solidFill>

</xml_diff>

<commit_message>
Explain cumulative yaw and quantile weighting directly on slide 07
</commit_message>
<xml_diff>
--- a/presentations/slide07_turn_weighting_cn.pptx
+++ b/presentations/slide07_turn_weighting_cn.pptx
@@ -517,7 +517,7 @@
           </a:p>
           <a:p>
             <a:r>
-              <a:t>B strictturn alpha2、C alpha3，其他1；strictturn来自GT endpoint lateral&gt;=.30m OR abs yawchange&gt;=45deg。D在训练帧累计绝对转角的33.333/66.667分位点按1/1.5/3分档，实际不是按每米曲率计算，故主页面改称累计转角分档。B/C/D独立方案，不将三个权重叠乘为同一实验。</a:t>
+              <a:t>B strictturn alpha2、C alpha3，其他1；strictturn来自GT endpoint lateral&gt;=.30m OR abs yawchange&gt;=45deg。D在训练帧累计绝对转角的33.333/66.667分位点按1/1.5/3分档，实际不是按每米曲率计算，故主页面改称累计转角分档。B/C/D独立方案，不将三个权重叠乘为同一实验。页面新增D分档公式：S=sum(k=1..8,abs(delta_yaw_k))；每步角差应wrap后再取绝对值。按训练帧S的33.333/66.667分位点划分低中高，alpha1/1.5/3；分界由训练数据决定，不是固定角度阈值。比如左转20再右转20的累计转角40deg，净航向变化0deg；累计与净变化不同。</a:t>
             </a:r>
           </a:p>
           <a:p>
@@ -3764,7 +3764,7 @@
         <p:spPr>
           <a:xfrm>
             <a:off x="685800" y="2185416"/>
-            <a:ext cx="5303520" cy="1078992"/>
+            <a:ext cx="5303520" cy="859536"/>
           </a:xfrm>
           <a:prstGeom prst="roundRect">
             <a:avLst>
@@ -3809,8 +3809,8 @@
         </p:nvSpPr>
         <p:spPr>
           <a:xfrm>
-            <a:off x="850392" y="2295144"/>
-            <a:ext cx="4974336" cy="274320"/>
+            <a:off x="850392" y="2258568"/>
+            <a:ext cx="4974336" cy="237744"/>
           </a:xfrm>
           <a:prstGeom prst="rect">
             <a:avLst/>
@@ -3828,7 +3828,7 @@
               <a:spcAft>
                 <a:spcPts val="700"/>
               </a:spcAft>
-              <a:defRPr sz="1500" b="1">
+              <a:defRPr sz="1300" b="1">
                 <a:solidFill>
                   <a:srgbClr val="142B46"/>
                 </a:solidFill>
@@ -3849,8 +3849,8 @@
         </p:nvSpPr>
         <p:spPr>
           <a:xfrm>
-            <a:off x="1051560" y="2761488"/>
-            <a:ext cx="1078992" cy="301752"/>
+            <a:off x="1051560" y="2660904"/>
+            <a:ext cx="1078992" cy="274320"/>
           </a:xfrm>
           <a:prstGeom prst="rect">
             <a:avLst/>
@@ -3868,7 +3868,7 @@
               <a:spcAft>
                 <a:spcPts val="700"/>
               </a:spcAft>
-              <a:defRPr sz="1900" b="1">
+              <a:defRPr sz="1800" b="1">
                 <a:solidFill>
                   <a:srgbClr val="142B46"/>
                 </a:solidFill>
@@ -3889,8 +3889,8 @@
         </p:nvSpPr>
         <p:spPr>
           <a:xfrm>
-            <a:off x="2304288" y="2651760"/>
-            <a:ext cx="2962656" cy="265176"/>
+            <a:off x="2304288" y="2523744"/>
+            <a:ext cx="2962656" cy="219456"/>
           </a:xfrm>
           <a:prstGeom prst="rect">
             <a:avLst/>
@@ -3908,7 +3908,7 @@
               <a:spcAft>
                 <a:spcPts val="700"/>
               </a:spcAft>
-              <a:defRPr sz="1900" b="0">
+              <a:defRPr sz="1800" b="0">
                 <a:solidFill>
                   <a:srgbClr val="142B46"/>
                 </a:solidFill>
@@ -3929,7 +3929,7 @@
         </p:nvCxnSpPr>
         <p:spPr>
           <a:xfrm>
-            <a:off x="2304288" y="2926080"/>
+            <a:off x="2304288" y="2761488"/>
             <a:ext cx="2962656" cy="0"/>
           </a:xfrm>
           <a:prstGeom prst="line">
@@ -3965,8 +3965,8 @@
         </p:nvSpPr>
         <p:spPr>
           <a:xfrm>
-            <a:off x="2304288" y="2971800"/>
-            <a:ext cx="2962656" cy="265176"/>
+            <a:off x="2304288" y="2788920"/>
+            <a:ext cx="2962656" cy="219456"/>
           </a:xfrm>
           <a:prstGeom prst="rect">
             <a:avLst/>
@@ -3984,7 +3984,7 @@
               <a:spcAft>
                 <a:spcPts val="700"/>
               </a:spcAft>
-              <a:defRPr sz="1900" b="0">
+              <a:defRPr sz="1800" b="0">
                 <a:solidFill>
                   <a:srgbClr val="142B46"/>
                 </a:solidFill>
@@ -4006,7 +4006,7 @@
         <p:spPr>
           <a:xfrm>
             <a:off x="6208776" y="2185416"/>
-            <a:ext cx="5303520" cy="1078992"/>
+            <a:ext cx="5303520" cy="859536"/>
           </a:xfrm>
           <a:prstGeom prst="roundRect">
             <a:avLst>
@@ -4051,8 +4051,8 @@
         </p:nvSpPr>
         <p:spPr>
           <a:xfrm>
-            <a:off x="6373368" y="2295144"/>
-            <a:ext cx="4974336" cy="274320"/>
+            <a:off x="6373368" y="2258568"/>
+            <a:ext cx="4974336" cy="237744"/>
           </a:xfrm>
           <a:prstGeom prst="rect">
             <a:avLst/>
@@ -4070,7 +4070,7 @@
               <a:spcAft>
                 <a:spcPts val="700"/>
               </a:spcAft>
-              <a:defRPr sz="1500" b="1">
+              <a:defRPr sz="1300" b="1">
                 <a:solidFill>
                   <a:srgbClr val="148D91"/>
                 </a:solidFill>
@@ -4091,8 +4091,8 @@
         </p:nvSpPr>
         <p:spPr>
           <a:xfrm>
-            <a:off x="6574536" y="2761488"/>
-            <a:ext cx="1078992" cy="301752"/>
+            <a:off x="6574536" y="2660904"/>
+            <a:ext cx="1078992" cy="274320"/>
           </a:xfrm>
           <a:prstGeom prst="rect">
             <a:avLst/>
@@ -4110,7 +4110,7 @@
               <a:spcAft>
                 <a:spcPts val="700"/>
               </a:spcAft>
-              <a:defRPr sz="1900" b="1">
+              <a:defRPr sz="1800" b="1">
                 <a:solidFill>
                   <a:srgbClr val="148D91"/>
                 </a:solidFill>
@@ -4131,8 +4131,8 @@
         </p:nvSpPr>
         <p:spPr>
           <a:xfrm>
-            <a:off x="7827264" y="2651760"/>
-            <a:ext cx="2962656" cy="265176"/>
+            <a:off x="7827264" y="2523744"/>
+            <a:ext cx="2962656" cy="219456"/>
           </a:xfrm>
           <a:prstGeom prst="rect">
             <a:avLst/>
@@ -4150,7 +4150,7 @@
               <a:spcAft>
                 <a:spcPts val="700"/>
               </a:spcAft>
-              <a:defRPr sz="1900" b="0">
+              <a:defRPr sz="1800" b="0">
                 <a:solidFill>
                   <a:srgbClr val="148D91"/>
                 </a:solidFill>
@@ -4171,7 +4171,7 @@
         </p:nvCxnSpPr>
         <p:spPr>
           <a:xfrm>
-            <a:off x="7827264" y="2926080"/>
+            <a:off x="7827264" y="2761488"/>
             <a:ext cx="2962656" cy="0"/>
           </a:xfrm>
           <a:prstGeom prst="line">
@@ -4207,8 +4207,8 @@
         </p:nvSpPr>
         <p:spPr>
           <a:xfrm>
-            <a:off x="7827264" y="2971800"/>
-            <a:ext cx="2962656" cy="265176"/>
+            <a:off x="7827264" y="2788920"/>
+            <a:ext cx="2962656" cy="219456"/>
           </a:xfrm>
           <a:prstGeom prst="rect">
             <a:avLst/>
@@ -4226,7 +4226,7 @@
               <a:spcAft>
                 <a:spcPts val="700"/>
               </a:spcAft>
-              <a:defRPr sz="1900" b="0">
+              <a:defRPr sz="1800" b="0">
                 <a:solidFill>
                   <a:srgbClr val="148D91"/>
                 </a:solidFill>
@@ -4247,87 +4247,7 @@
         </p:nvSpPr>
         <p:spPr>
           <a:xfrm>
-            <a:off x="685800" y="3410712"/>
-            <a:ext cx="10826496" cy="256032"/>
-          </a:xfrm>
-          <a:prstGeom prst="rect">
-            <a:avLst/>
-          </a:prstGeom>
-          <a:noFill/>
-          <a:effectLst/>
-        </p:spPr>
-        <p:txBody>
-          <a:bodyPr wrap="none" lIns="0" rIns="0" tIns="0" bIns="0">
-            <a:spAutoFit/>
-          </a:bodyPr>
-          <a:lstStyle/>
-          <a:p>
-            <a:pPr>
-              <a:spcAft>
-                <a:spcPts val="700"/>
-              </a:spcAft>
-              <a:defRPr sz="1200" b="0">
-                <a:solidFill>
-                  <a:srgbClr val="62748A"/>
-                </a:solidFill>
-                <a:latin typeface="Noto Sans CJK SC"/>
-              </a:defRPr>
-            </a:pPr>
-            <a:r>
-              <a:t>ℓᵢ：单样本方向损失；bᵢ：原有目标距离权重；αᵢ：本次新增的转弯权重。</a:t>
-            </a:r>
-          </a:p>
-        </p:txBody>
-      </p:sp>
-      <p:sp>
-        <p:nvSpPr>
-          <p:cNvPr id="20" name="TextBox 19"/>
-          <p:cNvSpPr txBox="1"/>
-          <p:nvPr/>
-        </p:nvSpPr>
-        <p:spPr>
-          <a:xfrm>
-            <a:off x="685800" y="3749039"/>
-            <a:ext cx="10826496" cy="256032"/>
-          </a:xfrm>
-          <a:prstGeom prst="rect">
-            <a:avLst/>
-          </a:prstGeom>
-          <a:noFill/>
-          <a:effectLst/>
-        </p:spPr>
-        <p:txBody>
-          <a:bodyPr wrap="none" lIns="0" rIns="0" tIns="0" bIns="0">
-            <a:spAutoFit/>
-          </a:bodyPr>
-          <a:lstStyle/>
-          <a:p>
-            <a:pPr>
-              <a:spcAft>
-                <a:spcPts val="700"/>
-              </a:spcAft>
-              <a:defRPr sz="1100" b="0">
-                <a:solidFill>
-                  <a:srgbClr val="142B46"/>
-                </a:solidFill>
-                <a:latin typeface="Noto Sans CJK SC"/>
-              </a:defRPr>
-            </a:pPr>
-            <a:r>
-              <a:t>B：转弯 α=2；C：转弯 α=3（其他样本均为 1）；D：累计转角低 / 中 / 高三档 α=1 / 1.5 / 3。</a:t>
-            </a:r>
-          </a:p>
-        </p:txBody>
-      </p:sp>
-      <p:sp>
-        <p:nvSpPr>
-          <p:cNvPr id="21" name="TextBox 20"/>
-          <p:cNvSpPr txBox="1"/>
-          <p:nvPr/>
-        </p:nvSpPr>
-        <p:spPr>
-          <a:xfrm>
-            <a:off x="685800" y="4078224"/>
+            <a:off x="685800" y="3172968"/>
             <a:ext cx="10826496" cy="228600"/>
           </a:xfrm>
           <a:prstGeom prst="rect">
@@ -4354,21 +4274,61 @@
               </a:defRPr>
             </a:pPr>
             <a:r>
-              <a:t>ℓᵢ 的计算：预热时 1−cosθᵢ；后续为 −κᵢ cosθᵢ + log I₀(κᵢ)（θᵢ 为方向误差，κᵢ 为方向集中度）。</a:t>
-            </a:r>
-          </a:p>
-        </p:txBody>
-      </p:sp>
-      <p:sp>
-        <p:nvSpPr>
-          <p:cNvPr id="22" name="Rounded Rectangle 21"/>
+              <a:t>ℓᵢ：单样本方向损失；bᵢ：原有目标距离权重；αᵢ：新增权重（B 转弯×2，C 转弯×3，其余×1）。</a:t>
+            </a:r>
+          </a:p>
+        </p:txBody>
+      </p:sp>
+      <p:sp>
+        <p:nvSpPr>
+          <p:cNvPr id="20" name="TextBox 19"/>
+          <p:cNvSpPr txBox="1"/>
+          <p:nvPr/>
+        </p:nvSpPr>
+        <p:spPr>
+          <a:xfrm>
+            <a:off x="685800" y="3483864"/>
+            <a:ext cx="10826496" cy="210312"/>
+          </a:xfrm>
+          <a:prstGeom prst="rect">
+            <a:avLst/>
+          </a:prstGeom>
+          <a:noFill/>
+          <a:effectLst/>
+        </p:spPr>
+        <p:txBody>
+          <a:bodyPr wrap="none" lIns="0" rIns="0" tIns="0" bIns="0">
+            <a:spAutoFit/>
+          </a:bodyPr>
+          <a:lstStyle/>
+          <a:p>
+            <a:pPr>
+              <a:spcAft>
+                <a:spcPts val="700"/>
+              </a:spcAft>
+              <a:defRPr sz="1000" b="0">
+                <a:solidFill>
+                  <a:srgbClr val="62748A"/>
+                </a:solidFill>
+                <a:latin typeface="Noto Sans CJK SC"/>
+              </a:defRPr>
+            </a:pPr>
+            <a:r>
+              <a:t>ℓᵢ：预热时 1−cosθᵢ；后续为 −κᵢ cosθᵢ + log I₀(κᵢ)（θᵢ 为方向误差，κᵢ 为方向集中度）。</a:t>
+            </a:r>
+          </a:p>
+        </p:txBody>
+      </p:sp>
+      <p:sp>
+        <p:nvSpPr>
+          <p:cNvPr id="21" name="Rounded Rectangle 20"/>
           <p:cNvSpPr/>
           <p:nvPr/>
         </p:nvSpPr>
         <p:spPr>
           <a:xfrm>
-            <a:off x="685800" y="4453128"/>
-            <a:ext cx="10826496" cy="329184"/>
+            <a:off x="685800" y="3803904"/>
+            <a:ext cx="10826496" cy="630936"/>
           </a:xfrm>
           <a:prstGeom prst="roundRect">
             <a:avLst>
@@ -4407,14 +4367,14 @@
       </p:sp>
       <p:sp>
         <p:nvSpPr>
-          <p:cNvPr id="23" name="TextBox 22"/>
+          <p:cNvPr id="22" name="TextBox 21"/>
           <p:cNvSpPr txBox="1"/>
           <p:nvPr/>
         </p:nvSpPr>
         <p:spPr>
           <a:xfrm>
-            <a:off x="841248" y="4526280"/>
-            <a:ext cx="2834640" cy="219456"/>
+            <a:off x="859536" y="3886200"/>
+            <a:ext cx="10424160" cy="246888"/>
           </a:xfrm>
           <a:prstGeom prst="rect">
             <a:avLst/>
@@ -4432,7 +4392,47 @@
               <a:spcAft>
                 <a:spcPts val="700"/>
               </a:spcAft>
-              <a:defRPr sz="1100" b="1">
+              <a:defRPr sz="1200" b="1">
+                <a:solidFill>
+                  <a:srgbClr val="142B46"/>
+                </a:solidFill>
+                <a:latin typeface="Noto Sans CJK SC"/>
+              </a:defRPr>
+            </a:pPr>
+            <a:r>
+              <a:t>D：累计转角 S = |Δψ₁| + … + |Δψ₈|，未来 8 步逐步取绝对值再相加，左右转都累加。</a:t>
+            </a:r>
+          </a:p>
+        </p:txBody>
+      </p:sp>
+      <p:sp>
+        <p:nvSpPr>
+          <p:cNvPr id="23" name="TextBox 22"/>
+          <p:cNvSpPr txBox="1"/>
+          <p:nvPr/>
+        </p:nvSpPr>
+        <p:spPr>
+          <a:xfrm>
+            <a:off x="859536" y="4242816"/>
+            <a:ext cx="10424160" cy="192024"/>
+          </a:xfrm>
+          <a:prstGeom prst="rect">
+            <a:avLst/>
+          </a:prstGeom>
+          <a:noFill/>
+          <a:effectLst/>
+        </p:spPr>
+        <p:txBody>
+          <a:bodyPr wrap="none" lIns="0" rIns="0" tIns="0" bIns="0">
+            <a:spAutoFit/>
+          </a:bodyPr>
+          <a:lstStyle/>
+          <a:p>
+            <a:pPr>
+              <a:spcAft>
+                <a:spcPts val="700"/>
+              </a:spcAft>
+              <a:defRPr sz="1000" b="0">
                 <a:solidFill>
                   <a:srgbClr val="62748A"/>
                 </a:solidFill>
@@ -4440,181 +4440,21 @@
               </a:defRPr>
             </a:pPr>
             <a:r>
-              <a:t>WP 训练方案</a:t>
-            </a:r>
-          </a:p>
-        </p:txBody>
-      </p:sp>
-      <p:sp>
-        <p:nvSpPr>
-          <p:cNvPr id="24" name="TextBox 23"/>
-          <p:cNvSpPr txBox="1"/>
-          <p:nvPr/>
-        </p:nvSpPr>
-        <p:spPr>
-          <a:xfrm>
-            <a:off x="4005072" y="4526280"/>
-            <a:ext cx="1773936" cy="219456"/>
-          </a:xfrm>
-          <a:prstGeom prst="rect">
-            <a:avLst/>
-          </a:prstGeom>
-          <a:noFill/>
-          <a:effectLst/>
-        </p:spPr>
-        <p:txBody>
-          <a:bodyPr wrap="none" lIns="0" rIns="0" tIns="0" bIns="0">
-            <a:spAutoFit/>
-          </a:bodyPr>
-          <a:lstStyle/>
-          <a:p>
-            <a:pPr algn="ctr">
-              <a:spcAft>
-                <a:spcPts val="700"/>
-              </a:spcAft>
-              <a:defRPr sz="1000" b="1">
-                <a:solidFill>
-                  <a:srgbClr val="62748A"/>
-                </a:solidFill>
-                <a:latin typeface="Noto Sans CJK SC"/>
-              </a:defRPr>
-            </a:pPr>
-            <a:r>
-              <a:t>全量中位误差 ↓</a:t>
-            </a:r>
-          </a:p>
-        </p:txBody>
-      </p:sp>
-      <p:sp>
-        <p:nvSpPr>
-          <p:cNvPr id="25" name="TextBox 24"/>
-          <p:cNvSpPr txBox="1"/>
-          <p:nvPr/>
-        </p:nvSpPr>
-        <p:spPr>
-          <a:xfrm>
-            <a:off x="5870448" y="4526280"/>
-            <a:ext cx="1773936" cy="219456"/>
-          </a:xfrm>
-          <a:prstGeom prst="rect">
-            <a:avLst/>
-          </a:prstGeom>
-          <a:noFill/>
-          <a:effectLst/>
-        </p:spPr>
-        <p:txBody>
-          <a:bodyPr wrap="none" lIns="0" rIns="0" tIns="0" bIns="0">
-            <a:spAutoFit/>
-          </a:bodyPr>
-          <a:lstStyle/>
-          <a:p>
-            <a:pPr algn="ctr">
-              <a:spcAft>
-                <a:spcPts val="700"/>
-              </a:spcAft>
-              <a:defRPr sz="1000" b="1">
-                <a:solidFill>
-                  <a:srgbClr val="62748A"/>
-                </a:solidFill>
-                <a:latin typeface="Noto Sans CJK SC"/>
-              </a:defRPr>
-            </a:pPr>
-            <a:r>
-              <a:t>转弯中位误差 ↓</a:t>
-            </a:r>
-          </a:p>
-        </p:txBody>
-      </p:sp>
-      <p:sp>
-        <p:nvSpPr>
-          <p:cNvPr id="26" name="TextBox 25"/>
-          <p:cNvSpPr txBox="1"/>
-          <p:nvPr/>
-        </p:nvSpPr>
-        <p:spPr>
-          <a:xfrm>
-            <a:off x="7735824" y="4526280"/>
-            <a:ext cx="1773936" cy="219456"/>
-          </a:xfrm>
-          <a:prstGeom prst="rect">
-            <a:avLst/>
-          </a:prstGeom>
-          <a:noFill/>
-          <a:effectLst/>
-        </p:spPr>
-        <p:txBody>
-          <a:bodyPr wrap="none" lIns="0" rIns="0" tIns="0" bIns="0">
-            <a:spAutoFit/>
-          </a:bodyPr>
-          <a:lstStyle/>
-          <a:p>
-            <a:pPr algn="ctr">
-              <a:spcAft>
-                <a:spcPts val="700"/>
-              </a:spcAft>
-              <a:defRPr sz="1000" b="1">
-                <a:solidFill>
-                  <a:srgbClr val="62748A"/>
-                </a:solidFill>
-                <a:latin typeface="Noto Sans CJK SC"/>
-              </a:defRPr>
-            </a:pPr>
-            <a:r>
-              <a:t>转弯 P90 ↓</a:t>
-            </a:r>
-          </a:p>
-        </p:txBody>
-      </p:sp>
-      <p:sp>
-        <p:nvSpPr>
-          <p:cNvPr id="27" name="TextBox 26"/>
-          <p:cNvSpPr txBox="1"/>
-          <p:nvPr/>
-        </p:nvSpPr>
-        <p:spPr>
-          <a:xfrm>
-            <a:off x="9601200" y="4526280"/>
-            <a:ext cx="1911095" cy="219456"/>
-          </a:xfrm>
-          <a:prstGeom prst="rect">
-            <a:avLst/>
-          </a:prstGeom>
-          <a:noFill/>
-          <a:effectLst/>
-        </p:spPr>
-        <p:txBody>
-          <a:bodyPr wrap="none" lIns="0" rIns="0" tIns="0" bIns="0">
-            <a:spAutoFit/>
-          </a:bodyPr>
-          <a:lstStyle/>
-          <a:p>
-            <a:pPr algn="ctr">
-              <a:spcAft>
-                <a:spcPts val="700"/>
-              </a:spcAft>
-              <a:defRPr sz="1000" b="1">
-                <a:solidFill>
-                  <a:srgbClr val="62748A"/>
-                </a:solidFill>
-                <a:latin typeface="Noto Sans CJK SC"/>
-              </a:defRPr>
-            </a:pPr>
-            <a:r>
-              <a:t>全量 &gt;45° 占比 ↓</a:t>
-            </a:r>
-          </a:p>
-        </p:txBody>
-      </p:sp>
-      <p:sp>
-        <p:nvSpPr>
-          <p:cNvPr id="28" name="Rounded Rectangle 27"/>
+              <a:t>按训练集 S 的 33% / 67% 分位点分档：低档 α=1；中档 α=1.5；高档 α=3。分界由训练数据确定。</a:t>
+            </a:r>
+          </a:p>
+        </p:txBody>
+      </p:sp>
+      <p:sp>
+        <p:nvSpPr>
+          <p:cNvPr id="24" name="Rounded Rectangle 23"/>
           <p:cNvSpPr/>
           <p:nvPr/>
         </p:nvSpPr>
         <p:spPr>
           <a:xfrm>
-            <a:off x="685800" y="4882896"/>
-            <a:ext cx="10826496" cy="265176"/>
+            <a:off x="685800" y="4562856"/>
+            <a:ext cx="10826496" cy="310896"/>
           </a:xfrm>
           <a:prstGeom prst="roundRect">
             <a:avLst>
@@ -4622,7 +4462,7 @@
             </a:avLst>
           </a:prstGeom>
           <a:solidFill>
-            <a:srgbClr val="E8F4F2"/>
+            <a:srgbClr val="ECF1F7"/>
           </a:solidFill>
           <a:ln>
             <a:noFill/>
@@ -4653,13 +4493,259 @@
       </p:sp>
       <p:sp>
         <p:nvSpPr>
+          <p:cNvPr id="25" name="TextBox 24"/>
+          <p:cNvSpPr txBox="1"/>
+          <p:nvPr/>
+        </p:nvSpPr>
+        <p:spPr>
+          <a:xfrm>
+            <a:off x="841248" y="4636008"/>
+            <a:ext cx="2834640" cy="219456"/>
+          </a:xfrm>
+          <a:prstGeom prst="rect">
+            <a:avLst/>
+          </a:prstGeom>
+          <a:noFill/>
+          <a:effectLst/>
+        </p:spPr>
+        <p:txBody>
+          <a:bodyPr wrap="none" lIns="0" rIns="0" tIns="0" bIns="0">
+            <a:spAutoFit/>
+          </a:bodyPr>
+          <a:lstStyle/>
+          <a:p>
+            <a:pPr>
+              <a:spcAft>
+                <a:spcPts val="700"/>
+              </a:spcAft>
+              <a:defRPr sz="1100" b="1">
+                <a:solidFill>
+                  <a:srgbClr val="62748A"/>
+                </a:solidFill>
+                <a:latin typeface="Noto Sans CJK SC"/>
+              </a:defRPr>
+            </a:pPr>
+            <a:r>
+              <a:t>WP 训练方案</a:t>
+            </a:r>
+          </a:p>
+        </p:txBody>
+      </p:sp>
+      <p:sp>
+        <p:nvSpPr>
+          <p:cNvPr id="26" name="TextBox 25"/>
+          <p:cNvSpPr txBox="1"/>
+          <p:nvPr/>
+        </p:nvSpPr>
+        <p:spPr>
+          <a:xfrm>
+            <a:off x="4005072" y="4636008"/>
+            <a:ext cx="1773936" cy="219456"/>
+          </a:xfrm>
+          <a:prstGeom prst="rect">
+            <a:avLst/>
+          </a:prstGeom>
+          <a:noFill/>
+          <a:effectLst/>
+        </p:spPr>
+        <p:txBody>
+          <a:bodyPr wrap="none" lIns="0" rIns="0" tIns="0" bIns="0">
+            <a:spAutoFit/>
+          </a:bodyPr>
+          <a:lstStyle/>
+          <a:p>
+            <a:pPr algn="ctr">
+              <a:spcAft>
+                <a:spcPts val="700"/>
+              </a:spcAft>
+              <a:defRPr sz="1000" b="1">
+                <a:solidFill>
+                  <a:srgbClr val="62748A"/>
+                </a:solidFill>
+                <a:latin typeface="Noto Sans CJK SC"/>
+              </a:defRPr>
+            </a:pPr>
+            <a:r>
+              <a:t>全量中位误差 ↓</a:t>
+            </a:r>
+          </a:p>
+        </p:txBody>
+      </p:sp>
+      <p:sp>
+        <p:nvSpPr>
+          <p:cNvPr id="27" name="TextBox 26"/>
+          <p:cNvSpPr txBox="1"/>
+          <p:nvPr/>
+        </p:nvSpPr>
+        <p:spPr>
+          <a:xfrm>
+            <a:off x="5870448" y="4636008"/>
+            <a:ext cx="1773936" cy="219456"/>
+          </a:xfrm>
+          <a:prstGeom prst="rect">
+            <a:avLst/>
+          </a:prstGeom>
+          <a:noFill/>
+          <a:effectLst/>
+        </p:spPr>
+        <p:txBody>
+          <a:bodyPr wrap="none" lIns="0" rIns="0" tIns="0" bIns="0">
+            <a:spAutoFit/>
+          </a:bodyPr>
+          <a:lstStyle/>
+          <a:p>
+            <a:pPr algn="ctr">
+              <a:spcAft>
+                <a:spcPts val="700"/>
+              </a:spcAft>
+              <a:defRPr sz="1000" b="1">
+                <a:solidFill>
+                  <a:srgbClr val="62748A"/>
+                </a:solidFill>
+                <a:latin typeface="Noto Sans CJK SC"/>
+              </a:defRPr>
+            </a:pPr>
+            <a:r>
+              <a:t>转弯中位误差 ↓</a:t>
+            </a:r>
+          </a:p>
+        </p:txBody>
+      </p:sp>
+      <p:sp>
+        <p:nvSpPr>
+          <p:cNvPr id="28" name="TextBox 27"/>
+          <p:cNvSpPr txBox="1"/>
+          <p:nvPr/>
+        </p:nvSpPr>
+        <p:spPr>
+          <a:xfrm>
+            <a:off x="7735824" y="4636008"/>
+            <a:ext cx="1773936" cy="219456"/>
+          </a:xfrm>
+          <a:prstGeom prst="rect">
+            <a:avLst/>
+          </a:prstGeom>
+          <a:noFill/>
+          <a:effectLst/>
+        </p:spPr>
+        <p:txBody>
+          <a:bodyPr wrap="none" lIns="0" rIns="0" tIns="0" bIns="0">
+            <a:spAutoFit/>
+          </a:bodyPr>
+          <a:lstStyle/>
+          <a:p>
+            <a:pPr algn="ctr">
+              <a:spcAft>
+                <a:spcPts val="700"/>
+              </a:spcAft>
+              <a:defRPr sz="1000" b="1">
+                <a:solidFill>
+                  <a:srgbClr val="62748A"/>
+                </a:solidFill>
+                <a:latin typeface="Noto Sans CJK SC"/>
+              </a:defRPr>
+            </a:pPr>
+            <a:r>
+              <a:t>转弯 P90 ↓</a:t>
+            </a:r>
+          </a:p>
+        </p:txBody>
+      </p:sp>
+      <p:sp>
+        <p:nvSpPr>
           <p:cNvPr id="29" name="TextBox 28"/>
           <p:cNvSpPr txBox="1"/>
           <p:nvPr/>
         </p:nvSpPr>
         <p:spPr>
           <a:xfrm>
-            <a:off x="841248" y="4901184"/>
+            <a:off x="9601200" y="4636008"/>
+            <a:ext cx="1911095" cy="219456"/>
+          </a:xfrm>
+          <a:prstGeom prst="rect">
+            <a:avLst/>
+          </a:prstGeom>
+          <a:noFill/>
+          <a:effectLst/>
+        </p:spPr>
+        <p:txBody>
+          <a:bodyPr wrap="none" lIns="0" rIns="0" tIns="0" bIns="0">
+            <a:spAutoFit/>
+          </a:bodyPr>
+          <a:lstStyle/>
+          <a:p>
+            <a:pPr algn="ctr">
+              <a:spcAft>
+                <a:spcPts val="700"/>
+              </a:spcAft>
+              <a:defRPr sz="1000" b="1">
+                <a:solidFill>
+                  <a:srgbClr val="62748A"/>
+                </a:solidFill>
+                <a:latin typeface="Noto Sans CJK SC"/>
+              </a:defRPr>
+            </a:pPr>
+            <a:r>
+              <a:t>全量 &gt;45° 占比 ↓</a:t>
+            </a:r>
+          </a:p>
+        </p:txBody>
+      </p:sp>
+      <p:sp>
+        <p:nvSpPr>
+          <p:cNvPr id="30" name="Rounded Rectangle 29"/>
+          <p:cNvSpPr/>
+          <p:nvPr/>
+        </p:nvSpPr>
+        <p:spPr>
+          <a:xfrm>
+            <a:off x="685800" y="4974336"/>
+            <a:ext cx="10826496" cy="265176"/>
+          </a:xfrm>
+          <a:prstGeom prst="roundRect">
+            <a:avLst>
+              <a:gd name="adj" fmla="val 12000"/>
+            </a:avLst>
+          </a:prstGeom>
+          <a:solidFill>
+            <a:srgbClr val="E8F4F2"/>
+          </a:solidFill>
+          <a:ln>
+            <a:noFill/>
+          </a:ln>
+          <a:effectLst/>
+        </p:spPr>
+        <p:style>
+          <a:lnRef idx="1">
+            <a:schemeClr val="accent1"/>
+          </a:lnRef>
+          <a:fillRef idx="3">
+            <a:schemeClr val="accent1"/>
+          </a:fillRef>
+          <a:effectRef idx="0">
+            <a:schemeClr val="accent1"/>
+          </a:effectRef>
+          <a:fontRef idx="minor">
+            <a:schemeClr val="lt1"/>
+          </a:fontRef>
+        </p:style>
+        <p:txBody>
+          <a:bodyPr rtlCol="0" anchor="ctr"/>
+          <a:lstStyle/>
+          <a:p>
+            <a:pPr algn="ctr"/>
+          </a:p>
+        </p:txBody>
+      </p:sp>
+      <p:sp>
+        <p:nvSpPr>
+          <p:cNvPr id="31" name="TextBox 30"/>
+          <p:cNvSpPr txBox="1"/>
+          <p:nvPr/>
+        </p:nvSpPr>
+        <p:spPr>
+          <a:xfrm>
+            <a:off x="841248" y="4992624"/>
             <a:ext cx="3108960" cy="237744"/>
           </a:xfrm>
           <a:prstGeom prst="rect">
@@ -4693,13 +4779,13 @@
       </p:sp>
       <p:sp>
         <p:nvSpPr>
-          <p:cNvPr id="30" name="TextBox 29"/>
+          <p:cNvPr id="32" name="TextBox 31"/>
           <p:cNvSpPr txBox="1"/>
           <p:nvPr/>
         </p:nvSpPr>
         <p:spPr>
           <a:xfrm>
-            <a:off x="4005072" y="4901184"/>
+            <a:off x="4005072" y="4992624"/>
             <a:ext cx="1773936" cy="246888"/>
           </a:xfrm>
           <a:prstGeom prst="rect">
@@ -4733,13 +4819,13 @@
       </p:sp>
       <p:sp>
         <p:nvSpPr>
-          <p:cNvPr id="31" name="TextBox 30"/>
+          <p:cNvPr id="33" name="TextBox 32"/>
           <p:cNvSpPr txBox="1"/>
           <p:nvPr/>
         </p:nvSpPr>
         <p:spPr>
           <a:xfrm>
-            <a:off x="5870448" y="4901184"/>
+            <a:off x="5870448" y="4992624"/>
             <a:ext cx="1773936" cy="246888"/>
           </a:xfrm>
           <a:prstGeom prst="rect">
@@ -4773,13 +4859,13 @@
       </p:sp>
       <p:sp>
         <p:nvSpPr>
-          <p:cNvPr id="32" name="TextBox 31"/>
+          <p:cNvPr id="34" name="TextBox 33"/>
           <p:cNvSpPr txBox="1"/>
           <p:nvPr/>
         </p:nvSpPr>
         <p:spPr>
           <a:xfrm>
-            <a:off x="7735824" y="4901184"/>
+            <a:off x="7735824" y="4992624"/>
             <a:ext cx="1773936" cy="246888"/>
           </a:xfrm>
           <a:prstGeom prst="rect">
@@ -4813,13 +4899,13 @@
       </p:sp>
       <p:sp>
         <p:nvSpPr>
-          <p:cNvPr id="33" name="TextBox 32"/>
+          <p:cNvPr id="35" name="TextBox 34"/>
           <p:cNvSpPr txBox="1"/>
           <p:nvPr/>
         </p:nvSpPr>
         <p:spPr>
           <a:xfrm>
-            <a:off x="9601200" y="4901184"/>
+            <a:off x="9601200" y="4992624"/>
             <a:ext cx="1911095" cy="246888"/>
           </a:xfrm>
           <a:prstGeom prst="rect">
@@ -4853,13 +4939,13 @@
       </p:sp>
       <p:sp>
         <p:nvSpPr>
-          <p:cNvPr id="34" name="TextBox 33"/>
+          <p:cNvPr id="36" name="TextBox 35"/>
           <p:cNvSpPr txBox="1"/>
           <p:nvPr/>
         </p:nvSpPr>
         <p:spPr>
           <a:xfrm>
-            <a:off x="841248" y="5175504"/>
+            <a:off x="841248" y="5257800"/>
             <a:ext cx="3108960" cy="237744"/>
           </a:xfrm>
           <a:prstGeom prst="rect">
@@ -4893,13 +4979,13 @@
       </p:sp>
       <p:sp>
         <p:nvSpPr>
-          <p:cNvPr id="35" name="TextBox 34"/>
+          <p:cNvPr id="37" name="TextBox 36"/>
           <p:cNvSpPr txBox="1"/>
           <p:nvPr/>
         </p:nvSpPr>
         <p:spPr>
           <a:xfrm>
-            <a:off x="4005072" y="5175504"/>
+            <a:off x="4005072" y="5257800"/>
             <a:ext cx="1773936" cy="246888"/>
           </a:xfrm>
           <a:prstGeom prst="rect">
@@ -4933,13 +5019,13 @@
       </p:sp>
       <p:sp>
         <p:nvSpPr>
-          <p:cNvPr id="36" name="TextBox 35"/>
+          <p:cNvPr id="38" name="TextBox 37"/>
           <p:cNvSpPr txBox="1"/>
           <p:nvPr/>
         </p:nvSpPr>
         <p:spPr>
           <a:xfrm>
-            <a:off x="5870448" y="5175504"/>
+            <a:off x="5870448" y="5257800"/>
             <a:ext cx="1773936" cy="246888"/>
           </a:xfrm>
           <a:prstGeom prst="rect">
@@ -4973,13 +5059,13 @@
       </p:sp>
       <p:sp>
         <p:nvSpPr>
-          <p:cNvPr id="37" name="TextBox 36"/>
+          <p:cNvPr id="39" name="TextBox 38"/>
           <p:cNvSpPr txBox="1"/>
           <p:nvPr/>
         </p:nvSpPr>
         <p:spPr>
           <a:xfrm>
-            <a:off x="7735824" y="5175504"/>
+            <a:off x="7735824" y="5257800"/>
             <a:ext cx="1773936" cy="246888"/>
           </a:xfrm>
           <a:prstGeom prst="rect">
@@ -5013,13 +5099,13 @@
       </p:sp>
       <p:sp>
         <p:nvSpPr>
-          <p:cNvPr id="38" name="TextBox 37"/>
+          <p:cNvPr id="40" name="TextBox 39"/>
           <p:cNvSpPr txBox="1"/>
           <p:nvPr/>
         </p:nvSpPr>
         <p:spPr>
           <a:xfrm>
-            <a:off x="9601200" y="5175504"/>
+            <a:off x="9601200" y="5257800"/>
             <a:ext cx="1911095" cy="246888"/>
           </a:xfrm>
           <a:prstGeom prst="rect">
@@ -5053,13 +5139,13 @@
       </p:sp>
       <p:cxnSp>
         <p:nvCxnSpPr>
-          <p:cNvPr id="39" name="Connector 38"/>
+          <p:cNvPr id="41" name="Connector 40"/>
           <p:cNvCxnSpPr/>
           <p:nvPr/>
         </p:nvCxnSpPr>
         <p:spPr>
           <a:xfrm>
-            <a:off x="685800" y="5422392"/>
+            <a:off x="685800" y="5504688"/>
             <a:ext cx="10826496" cy="0"/>
           </a:xfrm>
           <a:prstGeom prst="line">
@@ -5089,13 +5175,13 @@
       </p:cxnSp>
       <p:sp>
         <p:nvSpPr>
-          <p:cNvPr id="40" name="TextBox 39"/>
+          <p:cNvPr id="42" name="TextBox 41"/>
           <p:cNvSpPr txBox="1"/>
           <p:nvPr/>
         </p:nvSpPr>
         <p:spPr>
           <a:xfrm>
-            <a:off x="841248" y="5449824"/>
+            <a:off x="841248" y="5522976"/>
             <a:ext cx="3108960" cy="237744"/>
           </a:xfrm>
           <a:prstGeom prst="rect">
@@ -5129,13 +5215,13 @@
       </p:sp>
       <p:sp>
         <p:nvSpPr>
-          <p:cNvPr id="41" name="TextBox 40"/>
+          <p:cNvPr id="43" name="TextBox 42"/>
           <p:cNvSpPr txBox="1"/>
           <p:nvPr/>
         </p:nvSpPr>
         <p:spPr>
           <a:xfrm>
-            <a:off x="4005072" y="5449824"/>
+            <a:off x="4005072" y="5522976"/>
             <a:ext cx="1773936" cy="246888"/>
           </a:xfrm>
           <a:prstGeom prst="rect">
@@ -5169,13 +5255,13 @@
       </p:sp>
       <p:sp>
         <p:nvSpPr>
-          <p:cNvPr id="42" name="TextBox 41"/>
+          <p:cNvPr id="44" name="TextBox 43"/>
           <p:cNvSpPr txBox="1"/>
           <p:nvPr/>
         </p:nvSpPr>
         <p:spPr>
           <a:xfrm>
-            <a:off x="5870448" y="5449824"/>
+            <a:off x="5870448" y="5522976"/>
             <a:ext cx="1773936" cy="246888"/>
           </a:xfrm>
           <a:prstGeom prst="rect">
@@ -5209,13 +5295,13 @@
       </p:sp>
       <p:sp>
         <p:nvSpPr>
-          <p:cNvPr id="43" name="TextBox 42"/>
+          <p:cNvPr id="45" name="TextBox 44"/>
           <p:cNvSpPr txBox="1"/>
           <p:nvPr/>
         </p:nvSpPr>
         <p:spPr>
           <a:xfrm>
-            <a:off x="7735824" y="5449824"/>
+            <a:off x="7735824" y="5522976"/>
             <a:ext cx="1773936" cy="246888"/>
           </a:xfrm>
           <a:prstGeom prst="rect">
@@ -5249,13 +5335,13 @@
       </p:sp>
       <p:sp>
         <p:nvSpPr>
-          <p:cNvPr id="44" name="TextBox 43"/>
+          <p:cNvPr id="46" name="TextBox 45"/>
           <p:cNvSpPr txBox="1"/>
           <p:nvPr/>
         </p:nvSpPr>
         <p:spPr>
           <a:xfrm>
-            <a:off x="9601200" y="5449824"/>
+            <a:off x="9601200" y="5522976"/>
             <a:ext cx="1911095" cy="246888"/>
           </a:xfrm>
           <a:prstGeom prst="rect">
@@ -5289,13 +5375,13 @@
       </p:sp>
       <p:cxnSp>
         <p:nvCxnSpPr>
-          <p:cNvPr id="45" name="Connector 44"/>
+          <p:cNvPr id="47" name="Connector 46"/>
           <p:cNvCxnSpPr/>
           <p:nvPr/>
         </p:nvCxnSpPr>
         <p:spPr>
           <a:xfrm>
-            <a:off x="685800" y="5696712"/>
+            <a:off x="685800" y="5769864"/>
             <a:ext cx="10826496" cy="0"/>
           </a:xfrm>
           <a:prstGeom prst="line">
@@ -5325,13 +5411,13 @@
       </p:cxnSp>
       <p:sp>
         <p:nvSpPr>
-          <p:cNvPr id="46" name="TextBox 45"/>
+          <p:cNvPr id="48" name="TextBox 47"/>
           <p:cNvSpPr txBox="1"/>
           <p:nvPr/>
         </p:nvSpPr>
         <p:spPr>
           <a:xfrm>
-            <a:off x="841248" y="5724144"/>
+            <a:off x="841248" y="5788152"/>
             <a:ext cx="3108960" cy="237744"/>
           </a:xfrm>
           <a:prstGeom prst="rect">
@@ -5365,13 +5451,13 @@
       </p:sp>
       <p:sp>
         <p:nvSpPr>
-          <p:cNvPr id="47" name="TextBox 46"/>
+          <p:cNvPr id="49" name="TextBox 48"/>
           <p:cNvSpPr txBox="1"/>
           <p:nvPr/>
         </p:nvSpPr>
         <p:spPr>
           <a:xfrm>
-            <a:off x="4005072" y="5724144"/>
+            <a:off x="4005072" y="5788152"/>
             <a:ext cx="1773936" cy="246888"/>
           </a:xfrm>
           <a:prstGeom prst="rect">
@@ -5405,13 +5491,13 @@
       </p:sp>
       <p:sp>
         <p:nvSpPr>
-          <p:cNvPr id="48" name="TextBox 47"/>
+          <p:cNvPr id="50" name="TextBox 49"/>
           <p:cNvSpPr txBox="1"/>
           <p:nvPr/>
         </p:nvSpPr>
         <p:spPr>
           <a:xfrm>
-            <a:off x="5870448" y="5724144"/>
+            <a:off x="5870448" y="5788152"/>
             <a:ext cx="1773936" cy="246888"/>
           </a:xfrm>
           <a:prstGeom prst="rect">
@@ -5445,13 +5531,13 @@
       </p:sp>
       <p:sp>
         <p:nvSpPr>
-          <p:cNvPr id="49" name="TextBox 48"/>
+          <p:cNvPr id="51" name="TextBox 50"/>
           <p:cNvSpPr txBox="1"/>
           <p:nvPr/>
         </p:nvSpPr>
         <p:spPr>
           <a:xfrm>
-            <a:off x="7735824" y="5724144"/>
+            <a:off x="7735824" y="5788152"/>
             <a:ext cx="1773936" cy="246888"/>
           </a:xfrm>
           <a:prstGeom prst="rect">
@@ -5485,13 +5571,13 @@
       </p:sp>
       <p:sp>
         <p:nvSpPr>
-          <p:cNvPr id="50" name="TextBox 49"/>
+          <p:cNvPr id="52" name="TextBox 51"/>
           <p:cNvSpPr txBox="1"/>
           <p:nvPr/>
         </p:nvSpPr>
         <p:spPr>
           <a:xfrm>
-            <a:off x="9601200" y="5724144"/>
+            <a:off x="9601200" y="5788152"/>
             <a:ext cx="1911095" cy="246888"/>
           </a:xfrm>
           <a:prstGeom prst="rect">
@@ -5525,13 +5611,13 @@
       </p:sp>
       <p:cxnSp>
         <p:nvCxnSpPr>
-          <p:cNvPr id="51" name="Connector 50"/>
+          <p:cNvPr id="53" name="Connector 52"/>
           <p:cNvCxnSpPr/>
           <p:nvPr/>
         </p:nvCxnSpPr>
         <p:spPr>
           <a:xfrm>
-            <a:off x="685800" y="5971031"/>
+            <a:off x="685800" y="6035040"/>
             <a:ext cx="10826496" cy="0"/>
           </a:xfrm>
           <a:prstGeom prst="line">
@@ -5561,13 +5647,13 @@
       </p:cxnSp>
       <p:sp>
         <p:nvSpPr>
-          <p:cNvPr id="52" name="TextBox 51"/>
+          <p:cNvPr id="54" name="TextBox 53"/>
           <p:cNvSpPr txBox="1"/>
           <p:nvPr/>
         </p:nvSpPr>
         <p:spPr>
           <a:xfrm>
-            <a:off x="685800" y="6035040"/>
+            <a:off x="685800" y="6080760"/>
             <a:ext cx="10826496" cy="201168"/>
           </a:xfrm>
           <a:prstGeom prst="rect">
@@ -5601,7 +5687,7 @@
       </p:sp>
       <p:sp>
         <p:nvSpPr>
-          <p:cNvPr id="53" name="Rounded Rectangle 52"/>
+          <p:cNvPr id="55" name="Rounded Rectangle 54"/>
           <p:cNvSpPr/>
           <p:nvPr/>
         </p:nvSpPr>
@@ -5647,7 +5733,7 @@
       </p:sp>
       <p:sp>
         <p:nvSpPr>
-          <p:cNvPr id="54" name="TextBox 53"/>
+          <p:cNvPr id="56" name="TextBox 55"/>
           <p:cNvSpPr txBox="1"/>
           <p:nvPr/>
         </p:nvSpPr>
@@ -5687,7 +5773,7 @@
       </p:sp>
       <p:sp>
         <p:nvSpPr>
-          <p:cNvPr id="55" name="TextBox 54"/>
+          <p:cNvPr id="57" name="TextBox 56"/>
           <p:cNvSpPr txBox="1"/>
           <p:nvPr/>
         </p:nvSpPr>
@@ -5727,7 +5813,7 @@
       </p:sp>
       <p:sp>
         <p:nvSpPr>
-          <p:cNvPr id="56" name="TextBox 55"/>
+          <p:cNvPr id="58" name="TextBox 57"/>
           <p:cNvSpPr txBox="1"/>
           <p:nvPr/>
         </p:nvSpPr>

</xml_diff>